<commit_message>
Update user manual and statistical reference; add the fellow-eye simulation
- User manual: corrected text, the app's teal look (pptx and site PDF)
- Statistical reference and walkthrough: corrected against build 2026-10-02-se.9 (site PDF)
- validation/: simulate_fellow_eyes.R and its results (type I error of eye-level and patient-clustered tests)
- README: validation folder listed

Co-Authored-By: Claude Fable 5.1 <noreply@anthropic.com>
</commit_message>
<xml_diff>
--- a/User Manual - StandardEyes.pptx
+++ b/User Manual - StandardEyes.pptx
@@ -3116,7 +3116,7 @@
             <a:avLst/>
           </a:prstGeom>
           <a:solidFill>
-            <a:srgbClr val="3D2434"/>
+            <a:srgbClr val="0D2D2A"/>
           </a:solidFill>
           <a:ln>
             <a:noFill/>
@@ -3160,7 +3160,7 @@
             <a:avLst/>
           </a:prstGeom>
           <a:solidFill>
-            <a:srgbClr val="E6007E"/>
+            <a:srgbClr val="0F766E"/>
           </a:solidFill>
           <a:ln>
             <a:noFill/>
@@ -3187,13 +3187,13 @@
           <a:p>
             <a:pPr algn="ctr"/>
             <a:r>
-              <a:rPr sz="2200" b="1">
+              <a:rPr sz="1700" b="1">
                 <a:solidFill>
                   <a:srgbClr val="FFFFFF"/>
                 </a:solidFill>
                 <a:latin typeface="Calibri"/>
               </a:rPr>
-              <a:t>R</a:t>
+              <a:t>SE</a:t>
             </a:r>
           </a:p>
         </p:txBody>
@@ -3231,7 +3231,7 @@
             <a:r>
               <a:rPr sz="1500" b="1">
                 <a:solidFill>
-                  <a:srgbClr val="FDE7F3"/>
+                  <a:srgbClr val="E6F5F3"/>
                 </a:solidFill>
                 <a:latin typeface="Calibri"/>
               </a:rPr>
@@ -3310,7 +3310,7 @@
         <p:spPr>
           <a:xfrm>
             <a:off x="713232" y="4434840"/>
-            <a:ext cx="8229600" cy="365760"/>
+            <a:ext cx="10058400" cy="365760"/>
           </a:xfrm>
           <a:prstGeom prst="rect">
             <a:avLst/>
@@ -3334,11 +3334,11 @@
             <a:r>
               <a:rPr sz="1900" b="0">
                 <a:solidFill>
-                  <a:srgbClr val="FDE7F3"/>
-                </a:solidFill>
-                <a:latin typeface="Calibri"/>
-              </a:rPr>
-              <a:t>User manual &amp; walkthrough</a:t>
+                  <a:srgbClr val="E6F5F3"/>
+                </a:solidFill>
+                <a:latin typeface="Calibri"/>
+              </a:rPr>
+              <a:t>User manual &amp; walkthrough  ·  v1.0.0  ·  standardeyes.github.io</a:t>
             </a:r>
           </a:p>
         </p:txBody>
@@ -3376,7 +3376,7 @@
             <a:r>
               <a:rPr sz="1600" b="1">
                 <a:solidFill>
-                  <a:srgbClr val="FF6EB4"/>
+                  <a:srgbClr val="5EEAD4"/>
                 </a:solidFill>
                 <a:latin typeface="Calibri"/>
               </a:rPr>
@@ -3436,11 +3436,11 @@
             <a:r>
               <a:rPr sz="3800" b="1">
                 <a:solidFill>
-                  <a:srgbClr val="3D2434"/>
+                  <a:srgbClr val="0D2D2A"/>
                 </a:solidFill>
                 <a:latin typeface="Cambria"/>
               </a:rPr>
-              <a:t>Step 7 · Figures</a:t>
+              <a:t>Step 7 · Special outputs and figures</a:t>
             </a:r>
           </a:p>
         </p:txBody>
@@ -3478,11 +3478,11 @@
             <a:r>
               <a:rPr sz="1500" b="0">
                 <a:solidFill>
-                  <a:srgbClr val="71627C"/>
-                </a:solidFill>
-                <a:latin typeface="Calibri"/>
-              </a:rPr>
-              <a:t>One coherent suite — every option independently switchable</a:t>
+                  <a:srgbClr val="4F6763"/>
+                </a:solidFill>
+                <a:latin typeface="Calibri"/>
+              </a:rPr>
+              <a:t>Map the Column roles at the bottom of the tab first. Nothing is guessed from column names.</a:t>
             </a:r>
           </a:p>
         </p:txBody>
@@ -3496,13 +3496,13 @@
         <p:spPr>
           <a:xfrm>
             <a:off x="685800" y="1874519"/>
-            <a:ext cx="10789920" cy="932688"/>
+            <a:ext cx="10789920" cy="868680"/>
           </a:xfrm>
           <a:prstGeom prst="roundRect">
             <a:avLst/>
           </a:prstGeom>
           <a:solidFill>
-            <a:srgbClr val="FAF6F9"/>
+            <a:srgbClr val="F5FAF9"/>
           </a:solidFill>
           <a:ln>
             <a:noFill/>
@@ -3562,7 +3562,7 @@
             <a:r>
               <a:rPr sz="1600" b="1">
                 <a:solidFill>
-                  <a:srgbClr val="E6007E"/>
+                  <a:srgbClr val="0F766E"/>
                 </a:solidFill>
                 <a:latin typeface="Cambria"/>
               </a:rPr>
@@ -3604,11 +3604,11 @@
             <a:r>
               <a:rPr sz="1200" b="0">
                 <a:solidFill>
-                  <a:srgbClr val="71627C"/>
-                </a:solidFill>
-                <a:latin typeface="Calibri"/>
-              </a:rPr>
-              <a:t>EVERY group on one chart, however many. Omnibus + versus-reference statistics, clustered by patient. Panel sets: Full (nine), Refractive (six), Cataract (four); stability joins as an extra panel.</a:t>
+                  <a:srgbClr val="4F6763"/>
+                </a:solidFill>
+                <a:latin typeface="Calibri"/>
+              </a:rPr>
+              <a:t>EVERY group on one chart, readable up to about five. One overall test plus, with three or more groups, each group against the reference (Holm-adjusted), clustered by patient when a patient ID is set. Panel sets: Full (ten panels), Refractive (six), Cataract (four). Stability joins the Full set as an eleventh panel.</a:t>
             </a:r>
           </a:p>
         </p:txBody>
@@ -3621,14 +3621,14 @@
         </p:nvSpPr>
         <p:spPr>
           <a:xfrm>
-            <a:off x="685800" y="2935224"/>
-            <a:ext cx="10789920" cy="932688"/>
+            <a:off x="685800" y="2834639"/>
+            <a:ext cx="10789920" cy="868680"/>
           </a:xfrm>
           <a:prstGeom prst="roundRect">
             <a:avLst/>
           </a:prstGeom>
           <a:solidFill>
-            <a:srgbClr val="FAF6F9"/>
+            <a:srgbClr val="F5FAF9"/>
           </a:solidFill>
           <a:ln>
             <a:noFill/>
@@ -3663,7 +3663,7 @@
         </p:nvSpPr>
         <p:spPr>
           <a:xfrm>
-            <a:off x="1051560" y="3063240"/>
+            <a:off x="1051560" y="2962656"/>
             <a:ext cx="3017520" cy="320040"/>
           </a:xfrm>
           <a:prstGeom prst="rect">
@@ -3688,7 +3688,7 @@
             <a:r>
               <a:rPr sz="1600" b="1">
                 <a:solidFill>
-                  <a:srgbClr val="E6007E"/>
+                  <a:srgbClr val="0F766E"/>
                 </a:solidFill>
                 <a:latin typeface="Cambria"/>
               </a:rPr>
@@ -3705,7 +3705,7 @@
         </p:nvSpPr>
         <p:spPr>
           <a:xfrm>
-            <a:off x="4206240" y="3044952"/>
+            <a:off x="4206240" y="2944368"/>
             <a:ext cx="7040880" cy="731520"/>
           </a:xfrm>
           <a:prstGeom prst="rect">
@@ -3730,7 +3730,7 @@
             <a:r>
               <a:rPr sz="1200" b="0">
                 <a:solidFill>
-                  <a:srgbClr val="71627C"/>
+                  <a:srgbClr val="4F6763"/>
                 </a:solidFill>
                 <a:latin typeface="Calibri"/>
               </a:rPr>
@@ -3747,14 +3747,14 @@
         </p:nvSpPr>
         <p:spPr>
           <a:xfrm>
-            <a:off x="685800" y="3995928"/>
-            <a:ext cx="10789920" cy="932688"/>
+            <a:off x="685800" y="3794759"/>
+            <a:ext cx="10789920" cy="868680"/>
           </a:xfrm>
           <a:prstGeom prst="roundRect">
             <a:avLst/>
           </a:prstGeom>
           <a:solidFill>
-            <a:srgbClr val="FAF6F9"/>
+            <a:srgbClr val="F5FAF9"/>
           </a:solidFill>
           <a:ln>
             <a:noFill/>
@@ -3789,7 +3789,7 @@
         </p:nvSpPr>
         <p:spPr>
           <a:xfrm>
-            <a:off x="1051560" y="4123944"/>
+            <a:off x="1051560" y="3922775"/>
             <a:ext cx="3017520" cy="320040"/>
           </a:xfrm>
           <a:prstGeom prst="rect">
@@ -3814,7 +3814,7 @@
             <a:r>
               <a:rPr sz="1600" b="1">
                 <a:solidFill>
-                  <a:srgbClr val="E6007E"/>
+                  <a:srgbClr val="0F766E"/>
                 </a:solidFill>
                 <a:latin typeface="Cambria"/>
               </a:rPr>
@@ -3831,7 +3831,7 @@
         </p:nvSpPr>
         <p:spPr>
           <a:xfrm>
-            <a:off x="4206240" y="4105656"/>
+            <a:off x="4206240" y="3904487"/>
             <a:ext cx="7040880" cy="731520"/>
           </a:xfrm>
           <a:prstGeom prst="rect">
@@ -3856,7 +3856,7 @@
             <a:r>
               <a:rPr sz="1200" b="0">
                 <a:solidFill>
-                  <a:srgbClr val="71627C"/>
+                  <a:srgbClr val="4F6763"/>
                 </a:solidFill>
                 <a:latin typeface="Calibri"/>
               </a:rPr>
@@ -3873,14 +3873,14 @@
         </p:nvSpPr>
         <p:spPr>
           <a:xfrm>
-            <a:off x="685800" y="5056632"/>
-            <a:ext cx="10789920" cy="932688"/>
+            <a:off x="685800" y="4754879"/>
+            <a:ext cx="10789920" cy="868680"/>
           </a:xfrm>
           <a:prstGeom prst="roundRect">
             <a:avLst/>
           </a:prstGeom>
           <a:solidFill>
-            <a:srgbClr val="FAF6F9"/>
+            <a:srgbClr val="F5FAF9"/>
           </a:solidFill>
           <a:ln>
             <a:noFill/>
@@ -3915,7 +3915,7 @@
         </p:nvSpPr>
         <p:spPr>
           <a:xfrm>
-            <a:off x="1051560" y="5184648"/>
+            <a:off x="1051560" y="4882895"/>
             <a:ext cx="3017520" cy="320040"/>
           </a:xfrm>
           <a:prstGeom prst="rect">
@@ -3940,7 +3940,7 @@
             <a:r>
               <a:rPr sz="1600" b="1">
                 <a:solidFill>
-                  <a:srgbClr val="E6007E"/>
+                  <a:srgbClr val="0F766E"/>
                 </a:solidFill>
                 <a:latin typeface="Cambria"/>
               </a:rPr>
@@ -3957,7 +3957,7 @@
         </p:nvSpPr>
         <p:spPr>
           <a:xfrm>
-            <a:off x="4206240" y="5166360"/>
+            <a:off x="4206240" y="4864607"/>
             <a:ext cx="7040880" cy="731520"/>
           </a:xfrm>
           <a:prstGeom prst="rect">
@@ -3982,7 +3982,7 @@
             <a:r>
               <a:rPr sz="1200" b="0">
                 <a:solidFill>
-                  <a:srgbClr val="71627C"/>
+                  <a:srgbClr val="4F6763"/>
                 </a:solidFill>
                 <a:latin typeface="Calibri"/>
               </a:rPr>
@@ -3999,14 +3999,14 @@
         </p:nvSpPr>
         <p:spPr>
           <a:xfrm>
-            <a:off x="685800" y="6144768"/>
-            <a:ext cx="10789920" cy="566928"/>
+            <a:off x="685800" y="5715000"/>
+            <a:ext cx="10789920" cy="502920"/>
           </a:xfrm>
           <a:prstGeom prst="roundRect">
             <a:avLst/>
           </a:prstGeom>
           <a:solidFill>
-            <a:srgbClr val="FDE7F3"/>
+            <a:srgbClr val="E6F5F3"/>
           </a:solidFill>
           <a:ln>
             <a:noFill/>
@@ -4041,36 +4041,36 @@
         </p:nvSpPr>
         <p:spPr>
           <a:xfrm>
-            <a:off x="1051560" y="6272784"/>
-            <a:ext cx="10241280" cy="365760"/>
-          </a:xfrm>
-          <a:prstGeom prst="rect">
-            <a:avLst/>
-          </a:prstGeom>
-          <a:noFill/>
-        </p:spPr>
-        <p:txBody>
-          <a:bodyPr wrap="square" lIns="0" rIns="0" tIns="0" bIns="0" anchor="t">
-            <a:spAutoFit/>
-          </a:bodyPr>
-          <a:lstStyle/>
-          <a:p>
-            <a:pPr algn="l">
-              <a:lnSpc>
-                <a:spcPct val="115000"/>
-              </a:lnSpc>
-              <a:spcAft>
-                <a:spcPts val="600"/>
-              </a:spcAft>
-            </a:pPr>
-            <a:r>
-              <a:rPr sz="1250" b="0">
-                <a:solidFill>
-                  <a:srgbClr val="3D2434"/>
-                </a:solidFill>
-                <a:latin typeface="Calibri"/>
-              </a:rPr>
-              <a:t>Stability over time is mapped once and joins the composite as its own panel. Every panel is saved as its own TIFF (300 dpi default) and again inside the composite.</a:t>
+            <a:off x="1051560" y="5815584"/>
+            <a:ext cx="10241280" cy="320040"/>
+          </a:xfrm>
+          <a:prstGeom prst="rect">
+            <a:avLst/>
+          </a:prstGeom>
+          <a:noFill/>
+        </p:spPr>
+        <p:txBody>
+          <a:bodyPr wrap="square" lIns="0" rIns="0" tIns="0" bIns="0" anchor="t">
+            <a:spAutoFit/>
+          </a:bodyPr>
+          <a:lstStyle/>
+          <a:p>
+            <a:pPr algn="l">
+              <a:lnSpc>
+                <a:spcPct val="115000"/>
+              </a:lnSpc>
+              <a:spcAft>
+                <a:spcPts val="600"/>
+              </a:spcAft>
+            </a:pPr>
+            <a:r>
+              <a:rPr sz="1200" b="0">
+                <a:solidFill>
+                  <a:srgbClr val="0D2D2A"/>
+                </a:solidFill>
+                <a:latin typeface="Calibri"/>
+              </a:rPr>
+              <a:t>Every panel is also saved as its own TIFF (300 dpi by default), and the composites are previewed on the Run &amp; Results tab.</a:t>
             </a:r>
           </a:p>
         </p:txBody>
@@ -4108,7 +4108,7 @@
             <a:r>
               <a:rPr sz="1000" b="0">
                 <a:solidFill>
-                  <a:srgbClr val="71627C"/>
+                  <a:srgbClr val="4F6763"/>
                 </a:solidFill>
                 <a:latin typeface="Calibri"/>
               </a:rPr>
@@ -4150,7 +4150,7 @@
             <a:r>
               <a:rPr sz="1000" b="0">
                 <a:solidFill>
-                  <a:srgbClr val="71627C"/>
+                  <a:srgbClr val="4F6763"/>
                 </a:solidFill>
                 <a:latin typeface="Calibri"/>
               </a:rPr>
@@ -4210,7 +4210,7 @@
             <a:r>
               <a:rPr sz="3800" b="1">
                 <a:solidFill>
-                  <a:srgbClr val="3D2434"/>
+                  <a:srgbClr val="0D2D2A"/>
                 </a:solidFill>
                 <a:latin typeface="Cambria"/>
               </a:rPr>
@@ -4234,7 +4234,7 @@
             <a:avLst/>
           </a:prstGeom>
           <a:solidFill>
-            <a:srgbClr val="FAF6F9"/>
+            <a:srgbClr val="F5FAF9"/>
           </a:solidFill>
           <a:ln>
             <a:noFill/>
@@ -4294,11 +4294,11 @@
             <a:r>
               <a:rPr sz="1700" b="1">
                 <a:solidFill>
-                  <a:srgbClr val="3D2434"/>
+                  <a:srgbClr val="0D2D2A"/>
                 </a:solidFill>
                 <a:latin typeface="Cambria"/>
               </a:rPr>
-              <a:t>Saved only when you say so</a:t>
+              <a:t>Preview first, or save at once</a:t>
             </a:r>
           </a:p>
         </p:txBody>
@@ -4336,11 +4336,11 @@
             <a:r>
               <a:rPr sz="1300" b="0">
                 <a:solidFill>
-                  <a:srgbClr val="3D2434"/>
-                </a:solidFill>
-                <a:latin typeface="Calibri"/>
-              </a:rPr>
-              <a:t>Results are held inside the app first, so you can look through every sheet before anything reaches your output folder.</a:t>
+                  <a:srgbClr val="0D2D2A"/>
+                </a:solidFill>
+                <a:latin typeface="Calibri"/>
+              </a:rPr>
+              <a:t>Set the output folder in the left sidebar. ▶ RUN &amp; SAVE writes the results straight there.</a:t>
             </a:r>
           </a:p>
           <a:p>
@@ -4355,7 +4355,7 @@
             <a:r>
               <a:rPr sz="1300" b="0">
                 <a:solidFill>
-                  <a:srgbClr val="3D2434"/>
+                  <a:srgbClr val="0D2D2A"/>
                 </a:solidFill>
                 <a:latin typeface="Calibri"/>
               </a:rPr>
@@ -4374,11 +4374,11 @@
             <a:r>
               <a:rPr sz="1300" b="0">
                 <a:solidFill>
-                  <a:srgbClr val="3D2434"/>
-                </a:solidFill>
-                <a:latin typeface="Calibri"/>
-              </a:rPr>
-              <a:t>Meanwhile a temporary copy sits in the app's own folder; it is deleted at your next run or when you close the app.</a:t>
+                  <a:srgbClr val="0D2D2A"/>
+                </a:solidFill>
+                <a:latin typeface="Calibri"/>
+              </a:rPr>
+              <a:t>Tick Preview only first to keep them inside the app. A temporary copy waits in the app's own folder until your next run or until you close the app.</a:t>
             </a:r>
           </a:p>
           <a:p>
@@ -4393,7 +4393,7 @@
             <a:r>
               <a:rPr sz="1300" b="0">
                 <a:solidFill>
-                  <a:srgbClr val="3D2434"/>
+                  <a:srgbClr val="0D2D2A"/>
                 </a:solidFill>
                 <a:latin typeface="Calibri"/>
               </a:rPr>
@@ -4412,11 +4412,11 @@
             <a:r>
               <a:rPr sz="1300" b="0">
                 <a:solidFill>
-                  <a:srgbClr val="3D2434"/>
-                </a:solidFill>
-                <a:latin typeface="Calibri"/>
-              </a:rPr>
-              <a:t>When you are happy, choose the output folder and save.</a:t>
+                  <a:srgbClr val="0D2D2A"/>
+                </a:solidFill>
+                <a:latin typeface="Calibri"/>
+              </a:rPr>
+              <a:t>Then press Save ALL to output folder. It also copies the figures, love plots and filtered CSV. Save this one copies a single workbook.</a:t>
             </a:r>
           </a:p>
           <a:p>
@@ -4431,7 +4431,7 @@
             <a:r>
               <a:rPr sz="1300" b="0">
                 <a:solidFill>
-                  <a:srgbClr val="3D2434"/>
+                  <a:srgbClr val="0D2D2A"/>
                 </a:solidFill>
                 <a:latin typeface="Calibri"/>
               </a:rPr>
@@ -4450,11 +4450,11 @@
             <a:r>
               <a:rPr sz="1300" b="0">
                 <a:solidFill>
-                  <a:srgbClr val="3D2434"/>
-                </a:solidFill>
-                <a:latin typeface="Calibri"/>
-              </a:rPr>
-              <a:t>Progress and a full log are shown while R runs.</a:t>
+                  <a:srgbClr val="0D2D2A"/>
+                </a:solidFill>
+                <a:latin typeface="Calibri"/>
+              </a:rPr>
+              <a:t>Progress and a full log are shown while R runs. Cancel stops it.</a:t>
             </a:r>
           </a:p>
         </p:txBody>
@@ -4474,7 +4474,7 @@
             <a:avLst/>
           </a:prstGeom>
           <a:solidFill>
-            <a:srgbClr val="FAF6F9"/>
+            <a:srgbClr val="F5FAF9"/>
           </a:solidFill>
           <a:ln>
             <a:noFill/>
@@ -4534,7 +4534,7 @@
             <a:r>
               <a:rPr sz="1700" b="1">
                 <a:solidFill>
-                  <a:srgbClr val="3D2434"/>
+                  <a:srgbClr val="0D2D2A"/>
                 </a:solidFill>
                 <a:latin typeface="Cambria"/>
               </a:rPr>
@@ -4576,11 +4576,11 @@
             <a:r>
               <a:rPr sz="1300" b="0">
                 <a:solidFill>
-                  <a:srgbClr val="3D2434"/>
-                </a:solidFill>
-                <a:latin typeface="Calibri"/>
-              </a:rPr>
-              <a:t>•  Excel workbooks — summary, matching, GEE, regression</a:t>
+                  <a:srgbClr val="0D2D2A"/>
+                </a:solidFill>
+                <a:latin typeface="Calibri"/>
+              </a:rPr>
+              <a:t>•  Excel workbooks — summary, Publication Table, matching, GEE, regression, with a Contents and a Manifest sheet</a:t>
             </a:r>
           </a:p>
           <a:p>
@@ -4595,7 +4595,7 @@
             <a:r>
               <a:rPr sz="1300" b="0">
                 <a:solidFill>
-                  <a:srgbClr val="3D2434"/>
+                  <a:srgbClr val="0D2D2A"/>
                 </a:solidFill>
                 <a:latin typeface="Calibri"/>
               </a:rPr>
@@ -4614,11 +4614,11 @@
             <a:r>
               <a:rPr sz="1300" b="0">
                 <a:solidFill>
-                  <a:srgbClr val="3D2434"/>
-                </a:solidFill>
-                <a:latin typeface="Calibri"/>
-              </a:rPr>
-              <a:t>•  A figure folder per run, previewed in the app</a:t>
+                  <a:srgbClr val="0D2D2A"/>
+                </a:solidFill>
+                <a:latin typeface="Calibri"/>
+              </a:rPr>
+              <a:t>•  A love plot per matched pairing: LovePlot_&lt;prefix&gt;_&lt;subset&gt;_&lt;pairing&gt;_&lt;time stamp&gt;.png</a:t>
             </a:r>
           </a:p>
           <a:p>
@@ -4633,7 +4633,26 @@
             <a:r>
               <a:rPr sz="1300" b="0">
                 <a:solidFill>
-                  <a:srgbClr val="3D2434"/>
+                  <a:srgbClr val="0D2D2A"/>
+                </a:solidFill>
+                <a:latin typeface="Calibri"/>
+              </a:rPr>
+              <a:t>•  A figure folder per run. The combined figures are previewed in the app</a:t>
+            </a:r>
+          </a:p>
+          <a:p>
+            <a:pPr algn="l">
+              <a:lnSpc>
+                <a:spcPct val="115000"/>
+              </a:lnSpc>
+              <a:spcAft>
+                <a:spcPts val="400"/>
+              </a:spcAft>
+            </a:pPr>
+            <a:r>
+              <a:rPr sz="1300" b="0">
+                <a:solidFill>
+                  <a:srgbClr val="0D2D2A"/>
                 </a:solidFill>
                 <a:latin typeface="Calibri"/>
               </a:rPr>
@@ -4652,7 +4671,7 @@
             <a:r>
               <a:rPr sz="1300" b="0">
                 <a:solidFill>
-                  <a:srgbClr val="3D2434"/>
+                  <a:srgbClr val="0D2D2A"/>
                 </a:solidFill>
                 <a:latin typeface="Calibri"/>
               </a:rPr>
@@ -4671,11 +4690,11 @@
             <a:r>
               <a:rPr sz="1300" b="0">
                 <a:solidFill>
-                  <a:srgbClr val="3D2434"/>
-                </a:solidFill>
-                <a:latin typeface="Calibri"/>
-              </a:rPr>
-              <a:t>Adjusted effects and p-values are embedded in the main outcome table.</a:t>
+                  <a:srgbClr val="0D2D2A"/>
+                </a:solidFill>
+                <a:latin typeface="Calibri"/>
+              </a:rPr>
+              <a:t>When the regression runs, adjusted effects and p-values are embedded in the main outcome table.</a:t>
             </a:r>
           </a:p>
         </p:txBody>
@@ -4713,7 +4732,7 @@
             <a:r>
               <a:rPr sz="1000" b="0">
                 <a:solidFill>
-                  <a:srgbClr val="71627C"/>
+                  <a:srgbClr val="4F6763"/>
                 </a:solidFill>
                 <a:latin typeface="Calibri"/>
               </a:rPr>
@@ -4755,7 +4774,7 @@
             <a:r>
               <a:rPr sz="1000" b="0">
                 <a:solidFill>
-                  <a:srgbClr val="71627C"/>
+                  <a:srgbClr val="4F6763"/>
                 </a:solidFill>
                 <a:latin typeface="Calibri"/>
               </a:rPr>
@@ -4815,7 +4834,7 @@
             <a:r>
               <a:rPr sz="3800" b="1">
                 <a:solidFill>
-                  <a:srgbClr val="3D2434"/>
+                  <a:srgbClr val="0D2D2A"/>
                 </a:solidFill>
                 <a:latin typeface="Cambria"/>
               </a:rPr>
@@ -4857,7 +4876,7 @@
             <a:r>
               <a:rPr sz="1500" b="0">
                 <a:solidFill>
-                  <a:srgbClr val="71627C"/>
+                  <a:srgbClr val="4F6763"/>
                 </a:solidFill>
                 <a:latin typeface="Calibri"/>
               </a:rPr>
@@ -4881,7 +4900,7 @@
             <a:avLst/>
           </a:prstGeom>
           <a:solidFill>
-            <a:srgbClr val="FDE7F3"/>
+            <a:srgbClr val="E6F5F3"/>
           </a:solidFill>
           <a:ln>
             <a:noFill/>
@@ -4941,7 +4960,7 @@
             <a:r>
               <a:rPr sz="1500" b="0">
                 <a:solidFill>
-                  <a:srgbClr val="3D2434"/>
+                  <a:srgbClr val="0D2D2A"/>
                 </a:solidFill>
                 <a:latin typeface="Calibri"/>
               </a:rPr>
@@ -4965,7 +4984,7 @@
             <a:avLst/>
           </a:prstGeom>
           <a:solidFill>
-            <a:srgbClr val="E6007E"/>
+            <a:srgbClr val="0F766E"/>
           </a:solidFill>
           <a:ln>
             <a:noFill/>
@@ -5036,7 +5055,7 @@
             <a:r>
               <a:rPr sz="1450" b="1">
                 <a:solidFill>
-                  <a:srgbClr val="3D2434"/>
+                  <a:srgbClr val="0D2D2A"/>
                 </a:solidFill>
                 <a:latin typeface="Calibri"/>
               </a:rPr>
@@ -5078,7 +5097,7 @@
             <a:r>
               <a:rPr sz="1300" b="0">
                 <a:solidFill>
-                  <a:srgbClr val="71627C"/>
+                  <a:srgbClr val="4F6763"/>
                 </a:solidFill>
                 <a:latin typeface="Calibri"/>
               </a:rPr>
@@ -5102,7 +5121,7 @@
             <a:avLst/>
           </a:prstGeom>
           <a:solidFill>
-            <a:srgbClr val="E6007E"/>
+            <a:srgbClr val="0F766E"/>
           </a:solidFill>
           <a:ln>
             <a:noFill/>
@@ -5173,7 +5192,7 @@
             <a:r>
               <a:rPr sz="1450" b="1">
                 <a:solidFill>
-                  <a:srgbClr val="3D2434"/>
+                  <a:srgbClr val="0D2D2A"/>
                 </a:solidFill>
                 <a:latin typeface="Calibri"/>
               </a:rPr>
@@ -5215,11 +5234,11 @@
             <a:r>
               <a:rPr sz="1300" b="0">
                 <a:solidFill>
-                  <a:srgbClr val="71627C"/>
-                </a:solidFill>
-                <a:latin typeface="Calibri"/>
-              </a:rPr>
-              <a:t>Click the preset to restore the entire configuration.</a:t>
+                  <a:srgbClr val="4F6763"/>
+                </a:solidFill>
+                <a:latin typeface="Calibri"/>
+              </a:rPr>
+              <a:t>Load the Excel file, then click the preset to restore the entire configuration. A preset never loads the data file itself.</a:t>
             </a:r>
           </a:p>
         </p:txBody>
@@ -5239,7 +5258,7 @@
             <a:avLst/>
           </a:prstGeom>
           <a:solidFill>
-            <a:srgbClr val="E6007E"/>
+            <a:srgbClr val="0F766E"/>
           </a:solidFill>
           <a:ln>
             <a:noFill/>
@@ -5310,7 +5329,7 @@
             <a:r>
               <a:rPr sz="1450" b="1">
                 <a:solidFill>
-                  <a:srgbClr val="3D2434"/>
+                  <a:srgbClr val="0D2D2A"/>
                 </a:solidFill>
                 <a:latin typeface="Calibri"/>
               </a:rPr>
@@ -5352,11 +5371,11 @@
             <a:r>
               <a:rPr sz="1300" b="0">
                 <a:solidFill>
-                  <a:srgbClr val="71627C"/>
-                </a:solidFill>
-                <a:latin typeface="Calibri"/>
-              </a:rPr>
-              <a:t>Download the config as JSON and send it to a colleague — they load it and get your exact setup.</a:t>
+                  <a:srgbClr val="4F6763"/>
+                </a:solidFill>
+                <a:latin typeface="Calibri"/>
+              </a:rPr>
+              <a:t>Click Download config JSON and send it to a colleague. They click Load config JSON and get your exact setup. The data file is not inside, so they load their own copy of it.</a:t>
             </a:r>
           </a:p>
         </p:txBody>
@@ -5369,8 +5388,8 @@
         </p:nvSpPr>
         <p:spPr>
           <a:xfrm>
-            <a:off x="685800" y="5943600"/>
-            <a:ext cx="10789920" cy="365760"/>
+            <a:off x="685800" y="5852160"/>
+            <a:ext cx="10789920" cy="457200"/>
           </a:xfrm>
           <a:prstGeom prst="rect">
             <a:avLst/>
@@ -5394,11 +5413,11 @@
             <a:r>
               <a:rPr sz="1300" b="0">
                 <a:solidFill>
-                  <a:srgbClr val="71627C"/>
-                </a:solidFill>
-                <a:latin typeface="Calibri"/>
-              </a:rPr>
-              <a:t>Seven worked ‘Example – …’ presets are included (built on the bundled example dataset); presets you save appear beside them.</a:t>
+                  <a:srgbClr val="4F6763"/>
+                </a:solidFill>
+                <a:latin typeface="Calibri"/>
+              </a:rPr>
+              <a:t>Seven worked ‘Example – …’ presets are included. Load Example Data\Example_Refractive_Dataset.xlsx, click one, tick Preview only and press RUN. Presets you save appear beside them.</a:t>
             </a:r>
           </a:p>
         </p:txBody>
@@ -5436,7 +5455,7 @@
             <a:r>
               <a:rPr sz="1000" b="0">
                 <a:solidFill>
-                  <a:srgbClr val="71627C"/>
+                  <a:srgbClr val="4F6763"/>
                 </a:solidFill>
                 <a:latin typeface="Calibri"/>
               </a:rPr>
@@ -5478,7 +5497,7 @@
             <a:r>
               <a:rPr sz="1000" b="0">
                 <a:solidFill>
-                  <a:srgbClr val="71627C"/>
+                  <a:srgbClr val="4F6763"/>
                 </a:solidFill>
                 <a:latin typeface="Calibri"/>
               </a:rPr>
@@ -5538,7 +5557,7 @@
             <a:r>
               <a:rPr sz="3800" b="1">
                 <a:solidFill>
-                  <a:srgbClr val="3D2434"/>
+                  <a:srgbClr val="0D2D2A"/>
                 </a:solidFill>
                 <a:latin typeface="Cambria"/>
               </a:rPr>
@@ -5555,14 +5574,14 @@
         </p:nvSpPr>
         <p:spPr>
           <a:xfrm>
-            <a:off x="685800" y="1847088"/>
-            <a:ext cx="10789920" cy="566928"/>
+            <a:off x="685800" y="1755648"/>
+            <a:ext cx="10789920" cy="457200"/>
           </a:xfrm>
           <a:prstGeom prst="roundRect">
             <a:avLst/>
           </a:prstGeom>
           <a:solidFill>
-            <a:srgbClr val="FAF6F9"/>
+            <a:srgbClr val="F5FAF9"/>
           </a:solidFill>
           <a:ln>
             <a:noFill/>
@@ -5597,7 +5616,7 @@
         </p:nvSpPr>
         <p:spPr>
           <a:xfrm>
-            <a:off x="1005840" y="1984248"/>
+            <a:off x="1005840" y="1810512"/>
             <a:ext cx="3749039" cy="292608"/>
           </a:xfrm>
           <a:prstGeom prst="rect">
@@ -5622,11 +5641,11 @@
             <a:r>
               <a:rPr sz="1300" b="1">
                 <a:solidFill>
-                  <a:srgbClr val="E6007E"/>
-                </a:solidFill>
-                <a:latin typeface="Calibri"/>
-              </a:rPr>
-              <a:t>“Python runtime is missing”</a:t>
+                  <a:srgbClr val="0F766E"/>
+                </a:solidFill>
+                <a:latin typeface="Calibri"/>
+              </a:rPr>
+              <a:t>“Windows protected your PC”</a:t>
             </a:r>
           </a:p>
         </p:txBody>
@@ -5639,7 +5658,7 @@
         </p:nvSpPr>
         <p:spPr>
           <a:xfrm>
-            <a:off x="4892040" y="1984248"/>
+            <a:off x="4892040" y="1810512"/>
             <a:ext cx="6355080" cy="329184"/>
           </a:xfrm>
           <a:prstGeom prst="rect">
@@ -5664,11 +5683,11 @@
             <a:r>
               <a:rPr sz="1200" b="0">
                 <a:solidFill>
-                  <a:srgbClr val="71627C"/>
-                </a:solidFill>
-                <a:latin typeface="Calibri"/>
-              </a:rPr>
-              <a:t>The folder was copied incompletely, or is still inside a ZIP. Copy the whole folder again.</a:t>
+                  <a:srgbClr val="4F6763"/>
+                </a:solidFill>
+                <a:latin typeface="Calibri"/>
+              </a:rPr>
+              <a:t>Click More info, then Run anyway. To avoid it, tick Unblock in the ZIP’s Properties first.</a:t>
             </a:r>
           </a:p>
         </p:txBody>
@@ -5681,14 +5700,14 @@
         </p:nvSpPr>
         <p:spPr>
           <a:xfrm>
-            <a:off x="685800" y="2487168"/>
-            <a:ext cx="10789920" cy="566928"/>
+            <a:off x="685800" y="2258568"/>
+            <a:ext cx="10789920" cy="457200"/>
           </a:xfrm>
           <a:prstGeom prst="roundRect">
             <a:avLst/>
           </a:prstGeom>
           <a:solidFill>
-            <a:srgbClr val="FAF6F9"/>
+            <a:srgbClr val="F5FAF9"/>
           </a:solidFill>
           <a:ln>
             <a:noFill/>
@@ -5723,7 +5742,7 @@
         </p:nvSpPr>
         <p:spPr>
           <a:xfrm>
-            <a:off x="1005840" y="2624327"/>
+            <a:off x="1005840" y="2313432"/>
             <a:ext cx="3749039" cy="292608"/>
           </a:xfrm>
           <a:prstGeom prst="rect">
@@ -5748,11 +5767,11 @@
             <a:r>
               <a:rPr sz="1300" b="1">
                 <a:solidFill>
-                  <a:srgbClr val="E6007E"/>
-                </a:solidFill>
-                <a:latin typeface="Calibri"/>
-              </a:rPr>
-              <a:t>“Cannot write to its own folder”</a:t>
+                  <a:srgbClr val="0F766E"/>
+                </a:solidFill>
+                <a:latin typeface="Calibri"/>
+              </a:rPr>
+              <a:t>“Windows security blocked a component”</a:t>
             </a:r>
           </a:p>
         </p:txBody>
@@ -5765,7 +5784,7 @@
         </p:nvSpPr>
         <p:spPr>
           <a:xfrm>
-            <a:off x="4892040" y="2624327"/>
+            <a:off x="4892040" y="2313432"/>
             <a:ext cx="6355080" cy="329184"/>
           </a:xfrm>
           <a:prstGeom prst="rect">
@@ -5790,11 +5809,11 @@
             <a:r>
               <a:rPr sz="1200" b="0">
                 <a:solidFill>
-                  <a:srgbClr val="71627C"/>
-                </a:solidFill>
-                <a:latin typeface="Calibri"/>
-              </a:rPr>
-              <a:t>Move the whole folder somewhere you can write to (Documents, C:\StandardEyes) — not C:\Program Files.</a:t>
+                  <a:srgbClr val="4F6763"/>
+                </a:solidFill>
+                <a:latin typeface="Calibri"/>
+              </a:rPr>
+              <a:t>Smart App Control or an antivirus blocked the runtime. Ask IT to allow this folder.</a:t>
             </a:r>
           </a:p>
         </p:txBody>
@@ -5807,14 +5826,14 @@
         </p:nvSpPr>
         <p:spPr>
           <a:xfrm>
-            <a:off x="685800" y="3127248"/>
-            <a:ext cx="10789920" cy="566928"/>
+            <a:off x="685800" y="2761487"/>
+            <a:ext cx="10789920" cy="457200"/>
           </a:xfrm>
           <a:prstGeom prst="roundRect">
             <a:avLst/>
           </a:prstGeom>
           <a:solidFill>
-            <a:srgbClr val="FAF6F9"/>
+            <a:srgbClr val="F5FAF9"/>
           </a:solidFill>
           <a:ln>
             <a:noFill/>
@@ -5849,7 +5868,7 @@
         </p:nvSpPr>
         <p:spPr>
           <a:xfrm>
-            <a:off x="1005840" y="3264408"/>
+            <a:off x="1005840" y="2816351"/>
             <a:ext cx="3749039" cy="292608"/>
           </a:xfrm>
           <a:prstGeom prst="rect">
@@ -5874,11 +5893,11 @@
             <a:r>
               <a:rPr sz="1300" b="1">
                 <a:solidFill>
-                  <a:srgbClr val="E6007E"/>
-                </a:solidFill>
-                <a:latin typeface="Calibri"/>
-              </a:rPr>
-              <a:t>The browser shows nothing</a:t>
+                  <a:srgbClr val="0F766E"/>
+                </a:solidFill>
+                <a:latin typeface="Calibri"/>
+              </a:rPr>
+              <a:t>“Python runtime is missing”</a:t>
             </a:r>
           </a:p>
         </p:txBody>
@@ -5891,7 +5910,7 @@
         </p:nvSpPr>
         <p:spPr>
           <a:xfrm>
-            <a:off x="4892040" y="3264408"/>
+            <a:off x="4892040" y="2816351"/>
             <a:ext cx="6355080" cy="329184"/>
           </a:xfrm>
           <a:prstGeom prst="rect">
@@ -5916,11 +5935,11 @@
             <a:r>
               <a:rPr sz="1200" b="0">
                 <a:solidFill>
-                  <a:srgbClr val="71627C"/>
-                </a:solidFill>
-                <a:latin typeface="Calibri"/>
-              </a:rPr>
-              <a:t>Wait a few seconds, then reload the address printed in the console window.</a:t>
+                  <a:srgbClr val="4F6763"/>
+                </a:solidFill>
+                <a:latin typeface="Calibri"/>
+              </a:rPr>
+              <a:t>The folder was copied incompletely, or is still inside a ZIP. Copy the whole folder again.</a:t>
             </a:r>
           </a:p>
         </p:txBody>
@@ -5933,14 +5952,14 @@
         </p:nvSpPr>
         <p:spPr>
           <a:xfrm>
-            <a:off x="685800" y="3767328"/>
-            <a:ext cx="10789920" cy="566928"/>
+            <a:off x="685800" y="3264407"/>
+            <a:ext cx="10789920" cy="457200"/>
           </a:xfrm>
           <a:prstGeom prst="roundRect">
             <a:avLst/>
           </a:prstGeom>
           <a:solidFill>
-            <a:srgbClr val="FAF6F9"/>
+            <a:srgbClr val="F5FAF9"/>
           </a:solidFill>
           <a:ln>
             <a:noFill/>
@@ -5975,7 +5994,7 @@
         </p:nvSpPr>
         <p:spPr>
           <a:xfrm>
-            <a:off x="1005840" y="3904488"/>
+            <a:off x="1005840" y="3319271"/>
             <a:ext cx="3749039" cy="292608"/>
           </a:xfrm>
           <a:prstGeom prst="rect">
@@ -6000,11 +6019,11 @@
             <a:r>
               <a:rPr sz="1300" b="1">
                 <a:solidFill>
-                  <a:srgbClr val="E6007E"/>
-                </a:solidFill>
-                <a:latin typeface="Calibri"/>
-              </a:rPr>
-              <a:t>“R is not set up yet”</a:t>
+                  <a:srgbClr val="0F766E"/>
+                </a:solidFill>
+                <a:latin typeface="Calibri"/>
+              </a:rPr>
+              <a:t>“Cannot write to its own folder”</a:t>
             </a:r>
           </a:p>
         </p:txBody>
@@ -6017,7 +6036,7 @@
         </p:nvSpPr>
         <p:spPr>
           <a:xfrm>
-            <a:off x="4892040" y="3904488"/>
+            <a:off x="4892040" y="3319271"/>
             <a:ext cx="6355080" cy="329184"/>
           </a:xfrm>
           <a:prstGeom prst="rect">
@@ -6042,11 +6061,11 @@
             <a:r>
               <a:rPr sz="1200" b="0">
                 <a:solidFill>
-                  <a:srgbClr val="71627C"/>
-                </a:solidFill>
-                <a:latin typeface="Calibri"/>
-              </a:rPr>
-              <a:t>Click ⚙ R setup at the top right and point it at Rscript.exe.</a:t>
+                  <a:srgbClr val="4F6763"/>
+                </a:solidFill>
+                <a:latin typeface="Calibri"/>
+              </a:rPr>
+              <a:t>Move the whole folder to Documents or C:\StandardEyes, not C:\Program Files.</a:t>
             </a:r>
           </a:p>
         </p:txBody>
@@ -6059,14 +6078,14 @@
         </p:nvSpPr>
         <p:spPr>
           <a:xfrm>
-            <a:off x="685800" y="4407408"/>
-            <a:ext cx="10789920" cy="566928"/>
+            <a:off x="685800" y="3767327"/>
+            <a:ext cx="10789920" cy="457200"/>
           </a:xfrm>
           <a:prstGeom prst="roundRect">
             <a:avLst/>
           </a:prstGeom>
           <a:solidFill>
-            <a:srgbClr val="FAF6F9"/>
+            <a:srgbClr val="F5FAF9"/>
           </a:solidFill>
           <a:ln>
             <a:noFill/>
@@ -6101,7 +6120,7 @@
         </p:nvSpPr>
         <p:spPr>
           <a:xfrm>
-            <a:off x="1005840" y="4544568"/>
+            <a:off x="1005840" y="3822191"/>
             <a:ext cx="3749039" cy="292608"/>
           </a:xfrm>
           <a:prstGeom prst="rect">
@@ -6126,11 +6145,11 @@
             <a:r>
               <a:rPr sz="1300" b="1">
                 <a:solidFill>
-                  <a:srgbClr val="E6007E"/>
-                </a:solidFill>
-                <a:latin typeface="Calibri"/>
-              </a:rPr>
-              <a:t>A red “out of date” bar</a:t>
+                  <a:srgbClr val="0F766E"/>
+                </a:solidFill>
+                <a:latin typeface="Calibri"/>
+              </a:rPr>
+              <a:t>The browser shows nothing</a:t>
             </a:r>
           </a:p>
         </p:txBody>
@@ -6143,7 +6162,7 @@
         </p:nvSpPr>
         <p:spPr>
           <a:xfrm>
-            <a:off x="4892040" y="4544568"/>
+            <a:off x="4892040" y="3822191"/>
             <a:ext cx="6355080" cy="329184"/>
           </a:xfrm>
           <a:prstGeom prst="rect">
@@ -6168,11 +6187,11 @@
             <a:r>
               <a:rPr sz="1200" b="0">
                 <a:solidFill>
-                  <a:srgbClr val="71627C"/>
-                </a:solidFill>
-                <a:latin typeface="Calibri"/>
-              </a:rPr>
-              <a:t>Close the console window, start the app again, then press Ctrl+F5.</a:t>
+                  <a:srgbClr val="4F6763"/>
+                </a:solidFill>
+                <a:latin typeface="Calibri"/>
+              </a:rPr>
+              <a:t>Wait a few seconds, then reload the address printed in the console window.</a:t>
             </a:r>
           </a:p>
         </p:txBody>
@@ -6185,14 +6204,14 @@
         </p:nvSpPr>
         <p:spPr>
           <a:xfrm>
-            <a:off x="685800" y="5047488"/>
-            <a:ext cx="10789920" cy="566928"/>
+            <a:off x="685800" y="4270247"/>
+            <a:ext cx="10789920" cy="457200"/>
           </a:xfrm>
           <a:prstGeom prst="roundRect">
             <a:avLst/>
           </a:prstGeom>
           <a:solidFill>
-            <a:srgbClr val="FAF6F9"/>
+            <a:srgbClr val="F5FAF9"/>
           </a:solidFill>
           <a:ln>
             <a:noFill/>
@@ -6227,7 +6246,7 @@
         </p:nvSpPr>
         <p:spPr>
           <a:xfrm>
-            <a:off x="1005840" y="5184648"/>
+            <a:off x="1005840" y="4325111"/>
             <a:ext cx="3749039" cy="292608"/>
           </a:xfrm>
           <a:prstGeom prst="rect">
@@ -6252,11 +6271,11 @@
             <a:r>
               <a:rPr sz="1300" b="1">
                 <a:solidFill>
-                  <a:srgbClr val="E6007E"/>
-                </a:solidFill>
-                <a:latin typeface="Calibri"/>
-              </a:rPr>
-              <a:t>The analysis fails immediately</a:t>
+                  <a:srgbClr val="0F766E"/>
+                </a:solidFill>
+                <a:latin typeface="Calibri"/>
+              </a:rPr>
+              <a:t>“R is not set up yet”</a:t>
             </a:r>
           </a:p>
         </p:txBody>
@@ -6269,7 +6288,7 @@
         </p:nvSpPr>
         <p:spPr>
           <a:xfrm>
-            <a:off x="4892040" y="5184648"/>
+            <a:off x="4892040" y="4325111"/>
             <a:ext cx="6355080" cy="329184"/>
           </a:xfrm>
           <a:prstGeom prst="rect">
@@ -6294,11 +6313,11 @@
             <a:r>
               <a:rPr sz="1200" b="0">
                 <a:solidFill>
-                  <a:srgbClr val="71627C"/>
-                </a:solidFill>
-                <a:latin typeface="Calibri"/>
-              </a:rPr>
-              <a:t>Check your R version is 4.5.x and the VA notation of your file — the log says why.</a:t>
+                  <a:srgbClr val="4F6763"/>
+                </a:solidFill>
+                <a:latin typeface="Calibri"/>
+              </a:rPr>
+              <a:t>Click ⚙ R setup at the top right and point it at Rscript.exe.</a:t>
             </a:r>
           </a:p>
         </p:txBody>
@@ -6311,14 +6330,14 @@
         </p:nvSpPr>
         <p:spPr>
           <a:xfrm>
-            <a:off x="685800" y="5687568"/>
-            <a:ext cx="10789920" cy="566928"/>
+            <a:off x="685800" y="4773167"/>
+            <a:ext cx="10789920" cy="457200"/>
           </a:xfrm>
           <a:prstGeom prst="roundRect">
             <a:avLst/>
           </a:prstGeom>
           <a:solidFill>
-            <a:srgbClr val="FAF6F9"/>
+            <a:srgbClr val="F5FAF9"/>
           </a:solidFill>
           <a:ln>
             <a:noFill/>
@@ -6353,7 +6372,7 @@
         </p:nvSpPr>
         <p:spPr>
           <a:xfrm>
-            <a:off x="1005840" y="5824728"/>
+            <a:off x="1005840" y="4828031"/>
             <a:ext cx="3749039" cy="292608"/>
           </a:xfrm>
           <a:prstGeom prst="rect">
@@ -6378,7 +6397,259 @@
             <a:r>
               <a:rPr sz="1300" b="1">
                 <a:solidFill>
-                  <a:srgbClr val="E6007E"/>
+                  <a:srgbClr val="0F766E"/>
+                </a:solidFill>
+                <a:latin typeface="Calibri"/>
+              </a:rPr>
+              <a:t>A red “out of date” bar</a:t>
+            </a:r>
+          </a:p>
+        </p:txBody>
+      </p:sp>
+      <p:sp>
+        <p:nvSpPr>
+          <p:cNvPr id="23" name="TextBox 22"/>
+          <p:cNvSpPr txBox="1"/>
+          <p:nvPr/>
+        </p:nvSpPr>
+        <p:spPr>
+          <a:xfrm>
+            <a:off x="4892040" y="4828031"/>
+            <a:ext cx="6355080" cy="329184"/>
+          </a:xfrm>
+          <a:prstGeom prst="rect">
+            <a:avLst/>
+          </a:prstGeom>
+          <a:noFill/>
+        </p:spPr>
+        <p:txBody>
+          <a:bodyPr wrap="square" lIns="0" rIns="0" tIns="0" bIns="0" anchor="t">
+            <a:spAutoFit/>
+          </a:bodyPr>
+          <a:lstStyle/>
+          <a:p>
+            <a:pPr algn="l">
+              <a:lnSpc>
+                <a:spcPct val="115000"/>
+              </a:lnSpc>
+              <a:spcAft>
+                <a:spcPts val="600"/>
+              </a:spcAft>
+            </a:pPr>
+            <a:r>
+              <a:rPr sz="1200" b="0">
+                <a:solidFill>
+                  <a:srgbClr val="4F6763"/>
+                </a:solidFill>
+                <a:latin typeface="Calibri"/>
+              </a:rPr>
+              <a:t>Close the console window, start the app again, then press Ctrl+F5.</a:t>
+            </a:r>
+          </a:p>
+        </p:txBody>
+      </p:sp>
+      <p:sp>
+        <p:nvSpPr>
+          <p:cNvPr id="24" name="Rounded Rectangle 23"/>
+          <p:cNvSpPr/>
+          <p:nvPr/>
+        </p:nvSpPr>
+        <p:spPr>
+          <a:xfrm>
+            <a:off x="685800" y="5276087"/>
+            <a:ext cx="10789920" cy="457200"/>
+          </a:xfrm>
+          <a:prstGeom prst="roundRect">
+            <a:avLst/>
+          </a:prstGeom>
+          <a:solidFill>
+            <a:srgbClr val="F5FAF9"/>
+          </a:solidFill>
+          <a:ln>
+            <a:noFill/>
+          </a:ln>
+          <a:effectLst/>
+        </p:spPr>
+        <p:style>
+          <a:lnRef idx="1">
+            <a:schemeClr val="accent1"/>
+          </a:lnRef>
+          <a:fillRef idx="3">
+            <a:schemeClr val="accent1"/>
+          </a:fillRef>
+          <a:effectRef idx="2">
+            <a:schemeClr val="accent1"/>
+          </a:effectRef>
+          <a:fontRef idx="minor">
+            <a:schemeClr val="lt1"/>
+          </a:fontRef>
+        </p:style>
+        <p:txBody>
+          <a:bodyPr rtlCol="0" anchor="ctr"/>
+          <a:lstStyle/>
+          <a:p/>
+        </p:txBody>
+      </p:sp>
+      <p:sp>
+        <p:nvSpPr>
+          <p:cNvPr id="25" name="TextBox 24"/>
+          <p:cNvSpPr txBox="1"/>
+          <p:nvPr/>
+        </p:nvSpPr>
+        <p:spPr>
+          <a:xfrm>
+            <a:off x="1005840" y="5330951"/>
+            <a:ext cx="3749039" cy="292608"/>
+          </a:xfrm>
+          <a:prstGeom prst="rect">
+            <a:avLst/>
+          </a:prstGeom>
+          <a:noFill/>
+        </p:spPr>
+        <p:txBody>
+          <a:bodyPr wrap="square" lIns="0" rIns="0" tIns="0" bIns="0" anchor="t">
+            <a:spAutoFit/>
+          </a:bodyPr>
+          <a:lstStyle/>
+          <a:p>
+            <a:pPr algn="l">
+              <a:lnSpc>
+                <a:spcPct val="115000"/>
+              </a:lnSpc>
+              <a:spcAft>
+                <a:spcPts val="600"/>
+              </a:spcAft>
+            </a:pPr>
+            <a:r>
+              <a:rPr sz="1300" b="1">
+                <a:solidFill>
+                  <a:srgbClr val="0F766E"/>
+                </a:solidFill>
+                <a:latin typeface="Calibri"/>
+              </a:rPr>
+              <a:t>The analysis fails immediately</a:t>
+            </a:r>
+          </a:p>
+        </p:txBody>
+      </p:sp>
+      <p:sp>
+        <p:nvSpPr>
+          <p:cNvPr id="26" name="TextBox 25"/>
+          <p:cNvSpPr txBox="1"/>
+          <p:nvPr/>
+        </p:nvSpPr>
+        <p:spPr>
+          <a:xfrm>
+            <a:off x="4892040" y="5330951"/>
+            <a:ext cx="6355080" cy="329184"/>
+          </a:xfrm>
+          <a:prstGeom prst="rect">
+            <a:avLst/>
+          </a:prstGeom>
+          <a:noFill/>
+        </p:spPr>
+        <p:txBody>
+          <a:bodyPr wrap="square" lIns="0" rIns="0" tIns="0" bIns="0" anchor="t">
+            <a:spAutoFit/>
+          </a:bodyPr>
+          <a:lstStyle/>
+          <a:p>
+            <a:pPr algn="l">
+              <a:lnSpc>
+                <a:spcPct val="115000"/>
+              </a:lnSpc>
+              <a:spcAft>
+                <a:spcPts val="600"/>
+              </a:spcAft>
+            </a:pPr>
+            <a:r>
+              <a:rPr sz="1200" b="0">
+                <a:solidFill>
+                  <a:srgbClr val="4F6763"/>
+                </a:solidFill>
+                <a:latin typeface="Calibri"/>
+              </a:rPr>
+              <a:t>Check that R is version 4.5.x and the VA notation of your file. The log says why.</a:t>
+            </a:r>
+          </a:p>
+        </p:txBody>
+      </p:sp>
+      <p:sp>
+        <p:nvSpPr>
+          <p:cNvPr id="27" name="Rounded Rectangle 26"/>
+          <p:cNvSpPr/>
+          <p:nvPr/>
+        </p:nvSpPr>
+        <p:spPr>
+          <a:xfrm>
+            <a:off x="685800" y="5779007"/>
+            <a:ext cx="10789920" cy="457200"/>
+          </a:xfrm>
+          <a:prstGeom prst="roundRect">
+            <a:avLst/>
+          </a:prstGeom>
+          <a:solidFill>
+            <a:srgbClr val="F5FAF9"/>
+          </a:solidFill>
+          <a:ln>
+            <a:noFill/>
+          </a:ln>
+          <a:effectLst/>
+        </p:spPr>
+        <p:style>
+          <a:lnRef idx="1">
+            <a:schemeClr val="accent1"/>
+          </a:lnRef>
+          <a:fillRef idx="3">
+            <a:schemeClr val="accent1"/>
+          </a:fillRef>
+          <a:effectRef idx="2">
+            <a:schemeClr val="accent1"/>
+          </a:effectRef>
+          <a:fontRef idx="minor">
+            <a:schemeClr val="lt1"/>
+          </a:fontRef>
+        </p:style>
+        <p:txBody>
+          <a:bodyPr rtlCol="0" anchor="ctr"/>
+          <a:lstStyle/>
+          <a:p/>
+        </p:txBody>
+      </p:sp>
+      <p:sp>
+        <p:nvSpPr>
+          <p:cNvPr id="28" name="TextBox 27"/>
+          <p:cNvSpPr txBox="1"/>
+          <p:nvPr/>
+        </p:nvSpPr>
+        <p:spPr>
+          <a:xfrm>
+            <a:off x="1005840" y="5833871"/>
+            <a:ext cx="3749039" cy="292608"/>
+          </a:xfrm>
+          <a:prstGeom prst="rect">
+            <a:avLst/>
+          </a:prstGeom>
+          <a:noFill/>
+        </p:spPr>
+        <p:txBody>
+          <a:bodyPr wrap="square" lIns="0" rIns="0" tIns="0" bIns="0" anchor="t">
+            <a:spAutoFit/>
+          </a:bodyPr>
+          <a:lstStyle/>
+          <a:p>
+            <a:pPr algn="l">
+              <a:lnSpc>
+                <a:spcPct val="115000"/>
+              </a:lnSpc>
+              <a:spcAft>
+                <a:spcPts val="600"/>
+              </a:spcAft>
+            </a:pPr>
+            <a:r>
+              <a:rPr sz="1300" b="1">
+                <a:solidFill>
+                  <a:srgbClr val="0F766E"/>
                 </a:solidFill>
                 <a:latin typeface="Calibri"/>
               </a:rPr>
@@ -6389,13 +6660,13 @@
       </p:sp>
       <p:sp>
         <p:nvSpPr>
-          <p:cNvPr id="23" name="TextBox 22"/>
-          <p:cNvSpPr txBox="1"/>
-          <p:nvPr/>
-        </p:nvSpPr>
-        <p:spPr>
-          <a:xfrm>
-            <a:off x="4892040" y="5824728"/>
+          <p:cNvPr id="29" name="TextBox 28"/>
+          <p:cNvSpPr txBox="1"/>
+          <p:nvPr/>
+        </p:nvSpPr>
+        <p:spPr>
+          <a:xfrm>
+            <a:off x="4892040" y="5833871"/>
             <a:ext cx="6355080" cy="329184"/>
           </a:xfrm>
           <a:prstGeom prst="rect">
@@ -6420,18 +6691,18 @@
             <a:r>
               <a:rPr sz="1200" b="0">
                 <a:solidFill>
-                  <a:srgbClr val="71627C"/>
-                </a:solidFill>
-                <a:latin typeface="Calibri"/>
-              </a:rPr>
-              <a:t>The header says StandardEyes — By Noyman DBE, Mimouni M, Safir M — and a version such as v1.0.0 (build 2026-10-02-se.9).</a:t>
-            </a:r>
-          </a:p>
-        </p:txBody>
-      </p:sp>
-      <p:sp>
-        <p:nvSpPr>
-          <p:cNvPr id="24" name="TextBox 23"/>
+                  <a:srgbClr val="4F6763"/>
+                </a:solidFill>
+                <a:latin typeface="Calibri"/>
+              </a:rPr>
+              <a:t>The header shows StandardEyes and a version such as v1.0.0 (build 2026-10-02-se.9).</a:t>
+            </a:r>
+          </a:p>
+        </p:txBody>
+      </p:sp>
+      <p:sp>
+        <p:nvSpPr>
+          <p:cNvPr id="30" name="TextBox 29"/>
           <p:cNvSpPr txBox="1"/>
           <p:nvPr/>
         </p:nvSpPr>
@@ -6462,7 +6733,7 @@
             <a:r>
               <a:rPr sz="1000" b="0">
                 <a:solidFill>
-                  <a:srgbClr val="71627C"/>
+                  <a:srgbClr val="4F6763"/>
                 </a:solidFill>
                 <a:latin typeface="Calibri"/>
               </a:rPr>
@@ -6473,7 +6744,7 @@
       </p:sp>
       <p:sp>
         <p:nvSpPr>
-          <p:cNvPr id="25" name="TextBox 24"/>
+          <p:cNvPr id="31" name="TextBox 30"/>
           <p:cNvSpPr txBox="1"/>
           <p:nvPr/>
         </p:nvSpPr>
@@ -6504,7 +6775,7 @@
             <a:r>
               <a:rPr sz="1000" b="0">
                 <a:solidFill>
-                  <a:srgbClr val="71627C"/>
+                  <a:srgbClr val="4F6763"/>
                 </a:solidFill>
                 <a:latin typeface="Calibri"/>
               </a:rPr>
@@ -6546,7 +6817,7 @@
             <a:avLst/>
           </a:prstGeom>
           <a:solidFill>
-            <a:srgbClr val="3D2434"/>
+            <a:srgbClr val="0D2D2A"/>
           </a:solidFill>
           <a:ln>
             <a:noFill/>
@@ -6650,11 +6921,30 @@
             <a:r>
               <a:rPr sz="1700" b="0">
                 <a:solidFill>
-                  <a:srgbClr val="FDE7F3"/>
+                  <a:srgbClr val="E6F5F3"/>
                 </a:solidFill>
                 <a:latin typeface="Calibri"/>
               </a:rPr>
               <a:t>No data leaves the machine, no internet connection is needed, and no packages are ever installed.</a:t>
+            </a:r>
+          </a:p>
+          <a:p>
+            <a:pPr algn="l">
+              <a:lnSpc>
+                <a:spcPct val="115000"/>
+              </a:lnSpc>
+              <a:spcAft>
+                <a:spcPts val="600"/>
+              </a:spcAft>
+            </a:pPr>
+            <a:r>
+              <a:rPr sz="1700" b="0">
+                <a:solidFill>
+                  <a:srgbClr val="E6F5F3"/>
+                </a:solidFill>
+                <a:latin typeface="Calibri"/>
+              </a:rPr>
+              <a:t>Newer versions: standardeyes.github.io</a:t>
             </a:r>
           </a:p>
         </p:txBody>
@@ -6692,7 +6982,7 @@
             <a:r>
               <a:rPr sz="1500" b="0">
                 <a:solidFill>
-                  <a:srgbClr val="FDE7F3"/>
+                  <a:srgbClr val="E6F5F3"/>
                 </a:solidFill>
                 <a:latin typeface="Calibri"/>
               </a:rPr>
@@ -6734,7 +7024,7 @@
             <a:r>
               <a:rPr sz="1900" b="1">
                 <a:solidFill>
-                  <a:srgbClr val="FF6EB4"/>
+                  <a:srgbClr val="5EEAD4"/>
                 </a:solidFill>
                 <a:latin typeface="Calibri"/>
               </a:rPr>
@@ -6794,7 +7084,7 @@
             <a:r>
               <a:rPr sz="3800" b="1">
                 <a:solidFill>
-                  <a:srgbClr val="3D2434"/>
+                  <a:srgbClr val="0D2D2A"/>
                 </a:solidFill>
                 <a:latin typeface="Cambria"/>
               </a:rPr>
@@ -6836,7 +7126,7 @@
             <a:r>
               <a:rPr sz="1500" b="0">
                 <a:solidFill>
-                  <a:srgbClr val="71627C"/>
+                  <a:srgbClr val="4F6763"/>
                 </a:solidFill>
                 <a:latin typeface="Calibri"/>
               </a:rPr>
@@ -6860,7 +7150,7 @@
             <a:avLst/>
           </a:prstGeom>
           <a:solidFill>
-            <a:srgbClr val="FAF6F9"/>
+            <a:srgbClr val="F5FAF9"/>
           </a:solidFill>
           <a:ln>
             <a:noFill/>
@@ -6902,7 +7192,7 @@
             <a:avLst/>
           </a:prstGeom>
           <a:solidFill>
-            <a:srgbClr val="E6007E"/>
+            <a:srgbClr val="0F766E"/>
           </a:solidFill>
           <a:ln>
             <a:noFill/>
@@ -6973,7 +7263,7 @@
             <a:r>
               <a:rPr sz="1700" b="1">
                 <a:solidFill>
-                  <a:srgbClr val="3D2434"/>
+                  <a:srgbClr val="0D2D2A"/>
                 </a:solidFill>
                 <a:latin typeface="Calibri"/>
               </a:rPr>
@@ -7015,7 +7305,7 @@
             <a:r>
               <a:rPr sz="1300" b="0">
                 <a:solidFill>
-                  <a:srgbClr val="71627C"/>
+                  <a:srgbClr val="4F6763"/>
                 </a:solidFill>
                 <a:latin typeface="Calibri"/>
               </a:rPr>
@@ -7039,7 +7329,7 @@
             <a:avLst/>
           </a:prstGeom>
           <a:solidFill>
-            <a:srgbClr val="FAF6F9"/>
+            <a:srgbClr val="F5FAF9"/>
           </a:solidFill>
           <a:ln>
             <a:noFill/>
@@ -7081,7 +7371,7 @@
             <a:avLst/>
           </a:prstGeom>
           <a:solidFill>
-            <a:srgbClr val="E6007E"/>
+            <a:srgbClr val="0F766E"/>
           </a:solidFill>
           <a:ln>
             <a:noFill/>
@@ -7152,7 +7442,7 @@
             <a:r>
               <a:rPr sz="1700" b="1">
                 <a:solidFill>
-                  <a:srgbClr val="3D2434"/>
+                  <a:srgbClr val="0D2D2A"/>
                 </a:solidFill>
                 <a:latin typeface="Calibri"/>
               </a:rPr>
@@ -7194,11 +7484,11 @@
             <a:r>
               <a:rPr sz="1300" b="0">
                 <a:solidFill>
-                  <a:srgbClr val="71627C"/>
-                </a:solidFill>
-                <a:latin typeface="Calibri"/>
-              </a:rPr>
-              <a:t>Propensity-score matching (MatchIt) with a live matched-count preview and balance reporting.</a:t>
+                  <a:srgbClr val="4F6763"/>
+                </a:solidFill>
+                <a:latin typeface="Calibri"/>
+              </a:rPr>
+              <a:t>Matching with MatchIt (nearest neighbour on the propensity score, exact, coarsened exact or subclassification), with a live matched-count preview for nearest neighbour and balance reporting.</a:t>
             </a:r>
           </a:p>
         </p:txBody>
@@ -7218,7 +7508,7 @@
             <a:avLst/>
           </a:prstGeom>
           <a:solidFill>
-            <a:srgbClr val="FAF6F9"/>
+            <a:srgbClr val="F5FAF9"/>
           </a:solidFill>
           <a:ln>
             <a:noFill/>
@@ -7260,7 +7550,7 @@
             <a:avLst/>
           </a:prstGeom>
           <a:solidFill>
-            <a:srgbClr val="E6007E"/>
+            <a:srgbClr val="0F766E"/>
           </a:solidFill>
           <a:ln>
             <a:noFill/>
@@ -7331,7 +7621,7 @@
             <a:r>
               <a:rPr sz="1700" b="1">
                 <a:solidFill>
-                  <a:srgbClr val="3D2434"/>
+                  <a:srgbClr val="0D2D2A"/>
                 </a:solidFill>
                 <a:latin typeface="Calibri"/>
               </a:rPr>
@@ -7373,7 +7663,7 @@
             <a:r>
               <a:rPr sz="1300" b="0">
                 <a:solidFill>
-                  <a:srgbClr val="71627C"/>
+                  <a:srgbClr val="4F6763"/>
                 </a:solidFill>
                 <a:latin typeface="Calibri"/>
               </a:rPr>
@@ -7397,7 +7687,7 @@
             <a:avLst/>
           </a:prstGeom>
           <a:solidFill>
-            <a:srgbClr val="FAF6F9"/>
+            <a:srgbClr val="F5FAF9"/>
           </a:solidFill>
           <a:ln>
             <a:noFill/>
@@ -7439,7 +7729,7 @@
             <a:avLst/>
           </a:prstGeom>
           <a:solidFill>
-            <a:srgbClr val="E6007E"/>
+            <a:srgbClr val="0F766E"/>
           </a:solidFill>
           <a:ln>
             <a:noFill/>
@@ -7510,7 +7800,7 @@
             <a:r>
               <a:rPr sz="1700" b="1">
                 <a:solidFill>
-                  <a:srgbClr val="3D2434"/>
+                  <a:srgbClr val="0D2D2A"/>
                 </a:solidFill>
                 <a:latin typeface="Calibri"/>
               </a:rPr>
@@ -7552,7 +7842,7 @@
             <a:r>
               <a:rPr sz="1300" b="0">
                 <a:solidFill>
-                  <a:srgbClr val="71627C"/>
+                  <a:srgbClr val="4F6763"/>
                 </a:solidFill>
                 <a:latin typeface="Calibri"/>
               </a:rPr>
@@ -7594,7 +7884,7 @@
             <a:r>
               <a:rPr sz="1000" b="0">
                 <a:solidFill>
-                  <a:srgbClr val="71627C"/>
+                  <a:srgbClr val="4F6763"/>
                 </a:solidFill>
                 <a:latin typeface="Calibri"/>
               </a:rPr>
@@ -7636,7 +7926,7 @@
             <a:r>
               <a:rPr sz="1000" b="0">
                 <a:solidFill>
-                  <a:srgbClr val="71627C"/>
+                  <a:srgbClr val="4F6763"/>
                 </a:solidFill>
                 <a:latin typeface="Calibri"/>
               </a:rPr>
@@ -7696,7 +7986,7 @@
             <a:r>
               <a:rPr sz="3800" b="1">
                 <a:solidFill>
-                  <a:srgbClr val="3D2434"/>
+                  <a:srgbClr val="0D2D2A"/>
                 </a:solidFill>
                 <a:latin typeface="Cambria"/>
               </a:rPr>
@@ -7738,7 +8028,7 @@
             <a:r>
               <a:rPr sz="1500" b="0">
                 <a:solidFill>
-                  <a:srgbClr val="71627C"/>
+                  <a:srgbClr val="4F6763"/>
                 </a:solidFill>
                 <a:latin typeface="Calibri"/>
               </a:rPr>
@@ -7762,7 +8052,7 @@
             <a:avLst/>
           </a:prstGeom>
           <a:solidFill>
-            <a:srgbClr val="FDE7F3"/>
+            <a:srgbClr val="E6F5F3"/>
           </a:solidFill>
           <a:ln>
             <a:noFill/>
@@ -7804,7 +8094,7 @@
             <a:avLst/>
           </a:prstGeom>
           <a:solidFill>
-            <a:srgbClr val="E6007E"/>
+            <a:srgbClr val="0F766E"/>
           </a:solidFill>
           <a:ln>
             <a:noFill/>
@@ -7875,7 +8165,7 @@
             <a:r>
               <a:rPr sz="2000" b="1">
                 <a:solidFill>
-                  <a:srgbClr val="3D2434"/>
+                  <a:srgbClr val="0D2D2A"/>
                 </a:solidFill>
                 <a:latin typeface="Cambria"/>
               </a:rPr>
@@ -7917,7 +8207,7 @@
             <a:r>
               <a:rPr sz="1300" b="0">
                 <a:solidFill>
-                  <a:srgbClr val="3D2434"/>
+                  <a:srgbClr val="0D2D2A"/>
                 </a:solidFill>
                 <a:latin typeface="Calibri"/>
               </a:rPr>
@@ -7936,11 +8226,11 @@
             <a:r>
               <a:rPr sz="1300" b="0">
                 <a:solidFill>
-                  <a:srgbClr val="3D2434"/>
-                </a:solidFill>
-                <a:latin typeface="Calibri"/>
-              </a:rPr>
-              <a:t>Use R 4.5 (not 4.6 or later): cran.r-project.org/bin/windows/base/old/4.5.2/</a:t>
+                  <a:srgbClr val="0D2D2A"/>
+                </a:solidFill>
+                <a:latin typeface="Calibri"/>
+              </a:rPr>
+              <a:t>Use R 4.5.x, not 4.6 or an older R. CRAN's main page now offers 4.6. R 4.5.2 is at cran.r-project.org/bin/windows/base/old/4.5.2/</a:t>
             </a:r>
           </a:p>
           <a:p>
@@ -7955,7 +8245,7 @@
             <a:r>
               <a:rPr sz="1300" b="0">
                 <a:solidFill>
-                  <a:srgbClr val="3D2434"/>
+                  <a:srgbClr val="0D2D2A"/>
                 </a:solidFill>
                 <a:latin typeface="Calibri"/>
               </a:rPr>
@@ -7974,7 +8264,7 @@
             <a:r>
               <a:rPr sz="1300" b="0">
                 <a:solidFill>
-                  <a:srgbClr val="3D2434"/>
+                  <a:srgbClr val="0D2D2A"/>
                 </a:solidFill>
                 <a:latin typeface="Calibri"/>
               </a:rPr>
@@ -7993,7 +8283,7 @@
             <a:r>
               <a:rPr sz="1300" b="0">
                 <a:solidFill>
-                  <a:srgbClr val="3D2434"/>
+                  <a:srgbClr val="0D2D2A"/>
                 </a:solidFill>
                 <a:latin typeface="Calibri"/>
               </a:rPr>
@@ -8012,7 +8302,7 @@
             <a:r>
               <a:rPr sz="1300" b="0">
                 <a:solidFill>
-                  <a:srgbClr val="3D2434"/>
+                  <a:srgbClr val="0D2D2A"/>
                 </a:solidFill>
                 <a:latin typeface="Calibri"/>
               </a:rPr>
@@ -8031,7 +8321,7 @@
             <a:r>
               <a:rPr sz="1300" b="0">
                 <a:solidFill>
-                  <a:srgbClr val="3D2434"/>
+                  <a:srgbClr val="0D2D2A"/>
                 </a:solidFill>
                 <a:latin typeface="Calibri"/>
               </a:rPr>
@@ -8055,7 +8345,7 @@
             <a:avLst/>
           </a:prstGeom>
           <a:solidFill>
-            <a:srgbClr val="FAF6F9"/>
+            <a:srgbClr val="F5FAF9"/>
           </a:solidFill>
           <a:ln>
             <a:noFill/>
@@ -8168,7 +8458,7 @@
             <a:r>
               <a:rPr sz="2000" b="1">
                 <a:solidFill>
-                  <a:srgbClr val="3D2434"/>
+                  <a:srgbClr val="0D2D2A"/>
                 </a:solidFill>
                 <a:latin typeface="Cambria"/>
               </a:rPr>
@@ -8210,7 +8500,7 @@
             <a:r>
               <a:rPr sz="1300" b="0">
                 <a:solidFill>
-                  <a:srgbClr val="3D2434"/>
+                  <a:srgbClr val="0D2D2A"/>
                 </a:solidFill>
                 <a:latin typeface="Calibri"/>
               </a:rPr>
@@ -8229,7 +8519,7 @@
             <a:r>
               <a:rPr sz="1300" b="0">
                 <a:solidFill>
-                  <a:srgbClr val="3D2434"/>
+                  <a:srgbClr val="0D2D2A"/>
                 </a:solidFill>
                 <a:latin typeface="Calibri"/>
               </a:rPr>
@@ -8248,7 +8538,7 @@
             <a:r>
               <a:rPr sz="1300" b="0">
                 <a:solidFill>
-                  <a:srgbClr val="3D2434"/>
+                  <a:srgbClr val="0D2D2A"/>
                 </a:solidFill>
                 <a:latin typeface="Calibri"/>
               </a:rPr>
@@ -8267,7 +8557,7 @@
             <a:r>
               <a:rPr sz="1300" b="0">
                 <a:solidFill>
-                  <a:srgbClr val="3D2434"/>
+                  <a:srgbClr val="0D2D2A"/>
                 </a:solidFill>
                 <a:latin typeface="Calibri"/>
               </a:rPr>
@@ -8286,7 +8576,7 @@
             <a:r>
               <a:rPr sz="1300" b="0">
                 <a:solidFill>
-                  <a:srgbClr val="3D2434"/>
+                  <a:srgbClr val="0D2D2A"/>
                 </a:solidFill>
                 <a:latin typeface="Calibri"/>
               </a:rPr>
@@ -8328,7 +8618,7 @@
             <a:r>
               <a:rPr sz="1000" b="0">
                 <a:solidFill>
-                  <a:srgbClr val="71627C"/>
+                  <a:srgbClr val="4F6763"/>
                 </a:solidFill>
                 <a:latin typeface="Calibri"/>
               </a:rPr>
@@ -8370,7 +8660,7 @@
             <a:r>
               <a:rPr sz="1000" b="0">
                 <a:solidFill>
-                  <a:srgbClr val="71627C"/>
+                  <a:srgbClr val="4F6763"/>
                 </a:solidFill>
                 <a:latin typeface="Calibri"/>
               </a:rPr>
@@ -8430,7 +8720,7 @@
             <a:r>
               <a:rPr sz="3800" b="1">
                 <a:solidFill>
-                  <a:srgbClr val="3D2434"/>
+                  <a:srgbClr val="0D2D2A"/>
                 </a:solidFill>
                 <a:latin typeface="Cambria"/>
               </a:rPr>
@@ -8472,11 +8762,11 @@
             <a:r>
               <a:rPr sz="1500" b="0">
                 <a:solidFill>
-                  <a:srgbClr val="71627C"/>
-                </a:solidFill>
-                <a:latin typeface="Calibri"/>
-              </a:rPr>
-              <a:t>Three steps, once</a:t>
+                  <a:srgbClr val="4F6763"/>
+                </a:solidFill>
+                <a:latin typeface="Calibri"/>
+              </a:rPr>
+              <a:t>Copy once, then start it the same way every time</a:t>
             </a:r>
           </a:p>
         </p:txBody>
@@ -8496,7 +8786,7 @@
             <a:avLst/>
           </a:prstGeom>
           <a:solidFill>
-            <a:srgbClr val="E6007E"/>
+            <a:srgbClr val="0F766E"/>
           </a:solidFill>
           <a:ln>
             <a:noFill/>
@@ -8567,7 +8857,7 @@
             <a:r>
               <a:rPr sz="2000" b="1">
                 <a:solidFill>
-                  <a:srgbClr val="3D2434"/>
+                  <a:srgbClr val="0D2D2A"/>
                 </a:solidFill>
                 <a:latin typeface="Cambria"/>
               </a:rPr>
@@ -8609,11 +8899,11 @@
             <a:r>
               <a:rPr sz="1350" b="0">
                 <a:solidFill>
-                  <a:srgbClr val="71627C"/>
-                </a:solidFill>
-                <a:latin typeface="Calibri"/>
-              </a:rPr>
-              <a:t>Put it in a folder you can write to, e.g. C:\StandardEyes or Documents — not C:\Program Files. Keep every subfolder; don't run it from inside a ZIP.</a:t>
+                  <a:srgbClr val="4F6763"/>
+                </a:solidFill>
+                <a:latin typeface="Calibri"/>
+              </a:rPr>
+              <a:t>Download StandardEyes-windows.zip from standardeyes.github.io, right-click it, choose Properties and tick Unblock. Extract the whole folder where you can write, e.g. C:\StandardEyes or Documents, not C:\Program Files.</a:t>
             </a:r>
           </a:p>
         </p:txBody>
@@ -8633,7 +8923,7 @@
             <a:avLst/>
           </a:prstGeom>
           <a:solidFill>
-            <a:srgbClr val="E6007E"/>
+            <a:srgbClr val="0F766E"/>
           </a:solidFill>
           <a:ln>
             <a:noFill/>
@@ -8704,7 +8994,7 @@
             <a:r>
               <a:rPr sz="2000" b="1">
                 <a:solidFill>
-                  <a:srgbClr val="3D2434"/>
+                  <a:srgbClr val="0D2D2A"/>
                 </a:solidFill>
                 <a:latin typeface="Cambria"/>
               </a:rPr>
@@ -8746,7 +9036,7 @@
             <a:r>
               <a:rPr sz="1350" b="0">
                 <a:solidFill>
-                  <a:srgbClr val="71627C"/>
+                  <a:srgbClr val="4F6763"/>
                 </a:solidFill>
                 <a:latin typeface="Calibri"/>
               </a:rPr>
@@ -8770,7 +9060,7 @@
             <a:avLst/>
           </a:prstGeom>
           <a:solidFill>
-            <a:srgbClr val="E6007E"/>
+            <a:srgbClr val="0F766E"/>
           </a:solidFill>
           <a:ln>
             <a:noFill/>
@@ -8841,7 +9131,7 @@
             <a:r>
               <a:rPr sz="2000" b="1">
                 <a:solidFill>
-                  <a:srgbClr val="3D2434"/>
+                  <a:srgbClr val="0D2D2A"/>
                 </a:solidFill>
                 <a:latin typeface="Cambria"/>
               </a:rPr>
@@ -8883,7 +9173,7 @@
             <a:r>
               <a:rPr sz="1350" b="0">
                 <a:solidFill>
-                  <a:srgbClr val="71627C"/>
+                  <a:srgbClr val="4F6763"/>
                 </a:solidFill>
                 <a:latin typeface="Calibri"/>
               </a:rPr>
@@ -8907,7 +9197,7 @@
             <a:avLst/>
           </a:prstGeom>
           <a:solidFill>
-            <a:srgbClr val="FDE7F3"/>
+            <a:srgbClr val="E6F5F3"/>
           </a:solidFill>
           <a:ln>
             <a:noFill/>
@@ -8967,7 +9257,7 @@
             <a:r>
               <a:rPr sz="1350" b="1">
                 <a:solidFill>
-                  <a:srgbClr val="3D2434"/>
+                  <a:srgbClr val="0D2D2A"/>
                 </a:solidFill>
                 <a:latin typeface="Calibri"/>
               </a:rPr>
@@ -8976,7 +9266,7 @@
             <a:r>
               <a:rPr sz="1350" b="0">
                 <a:solidFill>
-                  <a:srgbClr val="3D2434"/>
+                  <a:srgbClr val="0D2D2A"/>
                 </a:solidFill>
                 <a:latin typeface="Calibri"/>
               </a:rPr>
@@ -9018,7 +9308,7 @@
             <a:r>
               <a:rPr sz="1000" b="0">
                 <a:solidFill>
-                  <a:srgbClr val="71627C"/>
+                  <a:srgbClr val="4F6763"/>
                 </a:solidFill>
                 <a:latin typeface="Calibri"/>
               </a:rPr>
@@ -9060,7 +9350,7 @@
             <a:r>
               <a:rPr sz="1000" b="0">
                 <a:solidFill>
-                  <a:srgbClr val="71627C"/>
+                  <a:srgbClr val="4F6763"/>
                 </a:solidFill>
                 <a:latin typeface="Calibri"/>
               </a:rPr>
@@ -9120,7 +9410,7 @@
             <a:r>
               <a:rPr sz="3800" b="1">
                 <a:solidFill>
-                  <a:srgbClr val="3D2434"/>
+                  <a:srgbClr val="0D2D2A"/>
                 </a:solidFill>
                 <a:latin typeface="Cambria"/>
               </a:rPr>
@@ -9162,7 +9452,7 @@
             <a:r>
               <a:rPr sz="1500" b="0">
                 <a:solidFill>
-                  <a:srgbClr val="71627C"/>
+                  <a:srgbClr val="4F6763"/>
                 </a:solidFill>
                 <a:latin typeface="Calibri"/>
               </a:rPr>
@@ -9186,7 +9476,7 @@
             <a:avLst/>
           </a:prstGeom>
           <a:solidFill>
-            <a:srgbClr val="FAF6F9"/>
+            <a:srgbClr val="F5FAF9"/>
           </a:solidFill>
           <a:ln>
             <a:noFill/>
@@ -9246,7 +9536,7 @@
             <a:r>
               <a:rPr sz="1500" b="1">
                 <a:solidFill>
-                  <a:srgbClr val="3D2434"/>
+                  <a:srgbClr val="0D2D2A"/>
                 </a:solidFill>
                 <a:latin typeface="Calibri"/>
               </a:rPr>
@@ -9270,7 +9560,7 @@
             <a:avLst/>
           </a:prstGeom>
           <a:solidFill>
-            <a:srgbClr val="E6007E"/>
+            <a:srgbClr val="0F766E"/>
           </a:solidFill>
           <a:ln>
             <a:noFill/>
@@ -9341,7 +9631,7 @@
             <a:r>
               <a:rPr sz="1350" b="1">
                 <a:solidFill>
-                  <a:srgbClr val="3D2434"/>
+                  <a:srgbClr val="0D2D2A"/>
                 </a:solidFill>
                 <a:latin typeface="Calibri"/>
               </a:rPr>
@@ -9383,7 +9673,7 @@
             <a:r>
               <a:rPr sz="1300" b="0">
                 <a:solidFill>
-                  <a:srgbClr val="71627C"/>
+                  <a:srgbClr val="4F6763"/>
                 </a:solidFill>
                 <a:latin typeface="Calibri"/>
               </a:rPr>
@@ -9407,7 +9697,7 @@
             <a:avLst/>
           </a:prstGeom>
           <a:solidFill>
-            <a:srgbClr val="E6007E"/>
+            <a:srgbClr val="0F766E"/>
           </a:solidFill>
           <a:ln>
             <a:noFill/>
@@ -9478,7 +9768,7 @@
             <a:r>
               <a:rPr sz="1350" b="1">
                 <a:solidFill>
-                  <a:srgbClr val="3D2434"/>
+                  <a:srgbClr val="0D2D2A"/>
                 </a:solidFill>
                 <a:latin typeface="Calibri"/>
               </a:rPr>
@@ -9520,7 +9810,7 @@
             <a:r>
               <a:rPr sz="1300" b="0">
                 <a:solidFill>
-                  <a:srgbClr val="71627C"/>
+                  <a:srgbClr val="4F6763"/>
                 </a:solidFill>
                 <a:latin typeface="Calibri"/>
               </a:rPr>
@@ -9544,7 +9834,7 @@
             <a:avLst/>
           </a:prstGeom>
           <a:solidFill>
-            <a:srgbClr val="E6007E"/>
+            <a:srgbClr val="0F766E"/>
           </a:solidFill>
           <a:ln>
             <a:noFill/>
@@ -9615,7 +9905,7 @@
             <a:r>
               <a:rPr sz="1350" b="1">
                 <a:solidFill>
-                  <a:srgbClr val="3D2434"/>
+                  <a:srgbClr val="0D2D2A"/>
                 </a:solidFill>
                 <a:latin typeface="Calibri"/>
               </a:rPr>
@@ -9657,7 +9947,7 @@
             <a:r>
               <a:rPr sz="1300" b="0">
                 <a:solidFill>
-                  <a:srgbClr val="71627C"/>
+                  <a:srgbClr val="4F6763"/>
                 </a:solidFill>
                 <a:latin typeface="Calibri"/>
               </a:rPr>
@@ -9699,11 +9989,11 @@
             <a:r>
               <a:rPr sz="1400" b="0">
                 <a:solidFill>
-                  <a:srgbClr val="3D2434"/>
-                </a:solidFill>
-                <a:latin typeface="Calibri"/>
-              </a:rPr>
-              <a:t>The app checks the choice immediately and reports the R version it found.</a:t>
+                  <a:srgbClr val="0D2D2A"/>
+                </a:solidFill>
+                <a:latin typeface="Calibri"/>
+              </a:rPr>
+              <a:t>The app checks the choice immediately and reports the R version it found, with a warning if it is not 4.5.x.</a:t>
             </a:r>
           </a:p>
         </p:txBody>
@@ -9723,7 +10013,7 @@
             <a:avLst/>
           </a:prstGeom>
           <a:solidFill>
-            <a:srgbClr val="FDE7F3"/>
+            <a:srgbClr val="E6F5F3"/>
           </a:solidFill>
           <a:ln>
             <a:noFill/>
@@ -9783,7 +10073,7 @@
             <a:r>
               <a:rPr sz="1350" b="1">
                 <a:solidFill>
-                  <a:srgbClr val="3D2434"/>
+                  <a:srgbClr val="0D2D2A"/>
                 </a:solidFill>
                 <a:latin typeface="Calibri"/>
               </a:rPr>
@@ -9792,11 +10082,11 @@
             <a:r>
               <a:rPr sz="1350" b="0">
                 <a:solidFill>
-                  <a:srgbClr val="3D2434"/>
-                </a:solidFill>
-                <a:latin typeface="Calibri"/>
-              </a:rPr>
-              <a:t>Install R 4.5.x for Windows, then click Re-check. No extra R packages are ever needed — this app brings its own.</a:t>
+                  <a:srgbClr val="0D2D2A"/>
+                </a:solidFill>
+                <a:latin typeface="Calibri"/>
+              </a:rPr>
+              <a:t>Install R 4.5.2 for Windows from cran.r-project.org/bin/windows/base/old/4.5.2/ (the main CRAN page offers a newer R), then click Re-check. No extra R packages are ever needed — this app brings its own.</a:t>
             </a:r>
           </a:p>
         </p:txBody>
@@ -9834,7 +10124,7 @@
             <a:r>
               <a:rPr sz="1250" b="0">
                 <a:solidFill>
-                  <a:srgbClr val="71627C"/>
+                  <a:srgbClr val="4F6763"/>
                 </a:solidFill>
                 <a:latin typeface="Calibri"/>
               </a:rPr>
@@ -9876,7 +10166,7 @@
             <a:r>
               <a:rPr sz="1000" b="0">
                 <a:solidFill>
-                  <a:srgbClr val="71627C"/>
+                  <a:srgbClr val="4F6763"/>
                 </a:solidFill>
                 <a:latin typeface="Calibri"/>
               </a:rPr>
@@ -9918,7 +10208,7 @@
             <a:r>
               <a:rPr sz="1000" b="0">
                 <a:solidFill>
-                  <a:srgbClr val="71627C"/>
+                  <a:srgbClr val="4F6763"/>
                 </a:solidFill>
                 <a:latin typeface="Calibri"/>
               </a:rPr>
@@ -9978,7 +10268,7 @@
             <a:r>
               <a:rPr sz="3800" b="1">
                 <a:solidFill>
-                  <a:srgbClr val="3D2434"/>
+                  <a:srgbClr val="0D2D2A"/>
                 </a:solidFill>
                 <a:latin typeface="Cambria"/>
               </a:rPr>
@@ -10020,7 +10310,7 @@
             <a:r>
               <a:rPr sz="1500" b="0">
                 <a:solidFill>
-                  <a:srgbClr val="71627C"/>
+                  <a:srgbClr val="4F6763"/>
                 </a:solidFill>
                 <a:latin typeface="Calibri"/>
               </a:rPr>
@@ -10044,7 +10334,7 @@
             <a:avLst/>
           </a:prstGeom>
           <a:solidFill>
-            <a:srgbClr val="FAF6F9"/>
+            <a:srgbClr val="F5FAF9"/>
           </a:solidFill>
           <a:ln>
             <a:noFill/>
@@ -10086,7 +10376,7 @@
             <a:avLst/>
           </a:prstGeom>
           <a:solidFill>
-            <a:srgbClr val="E6007E"/>
+            <a:srgbClr val="0F766E"/>
           </a:solidFill>
           <a:ln>
             <a:noFill/>
@@ -10157,7 +10447,7 @@
             <a:r>
               <a:rPr sz="1450" b="1">
                 <a:solidFill>
-                  <a:srgbClr val="3D2434"/>
+                  <a:srgbClr val="0D2D2A"/>
                 </a:solidFill>
                 <a:latin typeface="Calibri"/>
               </a:rPr>
@@ -10199,7 +10489,7 @@
             <a:r>
               <a:rPr sz="1150" b="0">
                 <a:solidFill>
-                  <a:srgbClr val="71627C"/>
+                  <a:srgbClr val="4F6763"/>
                 </a:solidFill>
                 <a:latin typeface="Calibri"/>
               </a:rPr>
@@ -10223,7 +10513,7 @@
             <a:avLst/>
           </a:prstGeom>
           <a:solidFill>
-            <a:srgbClr val="FAF6F9"/>
+            <a:srgbClr val="F5FAF9"/>
           </a:solidFill>
           <a:ln>
             <a:noFill/>
@@ -10265,7 +10555,7 @@
             <a:avLst/>
           </a:prstGeom>
           <a:solidFill>
-            <a:srgbClr val="E6007E"/>
+            <a:srgbClr val="0F766E"/>
           </a:solidFill>
           <a:ln>
             <a:noFill/>
@@ -10336,11 +10626,11 @@
             <a:r>
               <a:rPr sz="1450" b="1">
                 <a:solidFill>
-                  <a:srgbClr val="3D2434"/>
-                </a:solidFill>
-                <a:latin typeface="Calibri"/>
-              </a:rPr>
-              <a:t>Variables</a:t>
+                  <a:srgbClr val="0D2D2A"/>
+                </a:solidFill>
+                <a:latin typeface="Calibri"/>
+              </a:rPr>
+              <a:t>Variables &amp; Types</a:t>
             </a:r>
           </a:p>
         </p:txBody>
@@ -10378,11 +10668,11 @@
             <a:r>
               <a:rPr sz="1150" b="0">
                 <a:solidFill>
-                  <a:srgbClr val="71627C"/>
-                </a:solidFill>
-                <a:latin typeface="Calibri"/>
-              </a:rPr>
-              <a:t>Baseline / Preop / Outcome</a:t>
+                  <a:srgbClr val="4F6763"/>
+                </a:solidFill>
+                <a:latin typeface="Calibri"/>
+              </a:rPr>
+              <a:t>Sections, types, VA notation</a:t>
             </a:r>
           </a:p>
         </p:txBody>
@@ -10402,7 +10692,7 @@
             <a:avLst/>
           </a:prstGeom>
           <a:solidFill>
-            <a:srgbClr val="FAF6F9"/>
+            <a:srgbClr val="F5FAF9"/>
           </a:solidFill>
           <a:ln>
             <a:noFill/>
@@ -10444,7 +10734,7 @@
             <a:avLst/>
           </a:prstGeom>
           <a:solidFill>
-            <a:srgbClr val="E6007E"/>
+            <a:srgbClr val="0F766E"/>
           </a:solidFill>
           <a:ln>
             <a:noFill/>
@@ -10515,11 +10805,11 @@
             <a:r>
               <a:rPr sz="1450" b="1">
                 <a:solidFill>
-                  <a:srgbClr val="3D2434"/>
-                </a:solidFill>
-                <a:latin typeface="Calibri"/>
-              </a:rPr>
-              <a:t>Filters</a:t>
+                  <a:srgbClr val="0D2D2A"/>
+                </a:solidFill>
+                <a:latin typeface="Calibri"/>
+              </a:rPr>
+              <a:t>Filters &amp; Subsets</a:t>
             </a:r>
           </a:p>
         </p:txBody>
@@ -10557,7 +10847,7 @@
             <a:r>
               <a:rPr sz="1150" b="0">
                 <a:solidFill>
-                  <a:srgbClr val="71627C"/>
+                  <a:srgbClr val="4F6763"/>
                 </a:solidFill>
                 <a:latin typeface="Calibri"/>
               </a:rPr>
@@ -10581,7 +10871,7 @@
             <a:avLst/>
           </a:prstGeom>
           <a:solidFill>
-            <a:srgbClr val="FAF6F9"/>
+            <a:srgbClr val="F5FAF9"/>
           </a:solidFill>
           <a:ln>
             <a:noFill/>
@@ -10623,7 +10913,7 @@
             <a:avLst/>
           </a:prstGeom>
           <a:solidFill>
-            <a:srgbClr val="E6007E"/>
+            <a:srgbClr val="0F766E"/>
           </a:solidFill>
           <a:ln>
             <a:noFill/>
@@ -10694,7 +10984,7 @@
             <a:r>
               <a:rPr sz="1450" b="1">
                 <a:solidFill>
-                  <a:srgbClr val="3D2434"/>
+                  <a:srgbClr val="0D2D2A"/>
                 </a:solidFill>
                 <a:latin typeface="Calibri"/>
               </a:rPr>
@@ -10736,7 +11026,7 @@
             <a:r>
               <a:rPr sz="1150" b="0">
                 <a:solidFill>
-                  <a:srgbClr val="71627C"/>
+                  <a:srgbClr val="4F6763"/>
                 </a:solidFill>
                 <a:latin typeface="Calibri"/>
               </a:rPr>
@@ -10760,7 +11050,7 @@
             <a:avLst/>
           </a:prstGeom>
           <a:solidFill>
-            <a:srgbClr val="FAF6F9"/>
+            <a:srgbClr val="F5FAF9"/>
           </a:solidFill>
           <a:ln>
             <a:noFill/>
@@ -10802,7 +11092,7 @@
             <a:avLst/>
           </a:prstGeom>
           <a:solidFill>
-            <a:srgbClr val="E6007E"/>
+            <a:srgbClr val="0F766E"/>
           </a:solidFill>
           <a:ln>
             <a:noFill/>
@@ -10873,7 +11163,7 @@
             <a:r>
               <a:rPr sz="1450" b="1">
                 <a:solidFill>
-                  <a:srgbClr val="3D2434"/>
+                  <a:srgbClr val="0D2D2A"/>
                 </a:solidFill>
                 <a:latin typeface="Calibri"/>
               </a:rPr>
@@ -10915,7 +11205,7 @@
             <a:r>
               <a:rPr sz="1150" b="0">
                 <a:solidFill>
-                  <a:srgbClr val="71627C"/>
+                  <a:srgbClr val="4F6763"/>
                 </a:solidFill>
                 <a:latin typeface="Calibri"/>
               </a:rPr>
@@ -10939,7 +11229,7 @@
             <a:avLst/>
           </a:prstGeom>
           <a:solidFill>
-            <a:srgbClr val="FAF6F9"/>
+            <a:srgbClr val="F5FAF9"/>
           </a:solidFill>
           <a:ln>
             <a:noFill/>
@@ -10981,7 +11271,7 @@
             <a:avLst/>
           </a:prstGeom>
           <a:solidFill>
-            <a:srgbClr val="E6007E"/>
+            <a:srgbClr val="0F766E"/>
           </a:solidFill>
           <a:ln>
             <a:noFill/>
@@ -11052,7 +11342,7 @@
             <a:r>
               <a:rPr sz="1450" b="1">
                 <a:solidFill>
-                  <a:srgbClr val="3D2434"/>
+                  <a:srgbClr val="0D2D2A"/>
                 </a:solidFill>
                 <a:latin typeface="Calibri"/>
               </a:rPr>
@@ -11094,7 +11384,7 @@
             <a:r>
               <a:rPr sz="1150" b="0">
                 <a:solidFill>
-                  <a:srgbClr val="71627C"/>
+                  <a:srgbClr val="4F6763"/>
                 </a:solidFill>
                 <a:latin typeface="Calibri"/>
               </a:rPr>
@@ -11118,7 +11408,7 @@
             <a:avLst/>
           </a:prstGeom>
           <a:solidFill>
-            <a:srgbClr val="FAF6F9"/>
+            <a:srgbClr val="F5FAF9"/>
           </a:solidFill>
           <a:ln>
             <a:noFill/>
@@ -11160,7 +11450,7 @@
             <a:avLst/>
           </a:prstGeom>
           <a:solidFill>
-            <a:srgbClr val="E6007E"/>
+            <a:srgbClr val="0F766E"/>
           </a:solidFill>
           <a:ln>
             <a:noFill/>
@@ -11231,7 +11521,7 @@
             <a:r>
               <a:rPr sz="1450" b="1">
                 <a:solidFill>
-                  <a:srgbClr val="3D2434"/>
+                  <a:srgbClr val="0D2D2A"/>
                 </a:solidFill>
                 <a:latin typeface="Calibri"/>
               </a:rPr>
@@ -11273,11 +11563,11 @@
             <a:r>
               <a:rPr sz="1150" b="0">
                 <a:solidFill>
-                  <a:srgbClr val="71627C"/>
-                </a:solidFill>
-                <a:latin typeface="Calibri"/>
-              </a:rPr>
-              <a:t>Figures</a:t>
+                  <a:srgbClr val="4F6763"/>
+                </a:solidFill>
+                <a:latin typeface="Calibri"/>
+              </a:rPr>
+              <a:t>Column roles, figures, export tabs</a:t>
             </a:r>
           </a:p>
         </p:txBody>
@@ -11297,7 +11587,7 @@
             <a:avLst/>
           </a:prstGeom>
           <a:solidFill>
-            <a:srgbClr val="FAF6F9"/>
+            <a:srgbClr val="F5FAF9"/>
           </a:solidFill>
           <a:ln>
             <a:noFill/>
@@ -11339,7 +11629,7 @@
             <a:avLst/>
           </a:prstGeom>
           <a:solidFill>
-            <a:srgbClr val="E6007E"/>
+            <a:srgbClr val="0F766E"/>
           </a:solidFill>
           <a:ln>
             <a:noFill/>
@@ -11410,7 +11700,7 @@
             <a:r>
               <a:rPr sz="1450" b="1">
                 <a:solidFill>
-                  <a:srgbClr val="3D2434"/>
+                  <a:srgbClr val="0D2D2A"/>
                 </a:solidFill>
                 <a:latin typeface="Calibri"/>
               </a:rPr>
@@ -11452,7 +11742,7 @@
             <a:r>
               <a:rPr sz="1150" b="0">
                 <a:solidFill>
-                  <a:srgbClr val="71627C"/>
+                  <a:srgbClr val="4F6763"/>
                 </a:solidFill>
                 <a:latin typeface="Calibri"/>
               </a:rPr>
@@ -11494,7 +11784,7 @@
             <a:r>
               <a:rPr sz="1000" b="0">
                 <a:solidFill>
-                  <a:srgbClr val="71627C"/>
+                  <a:srgbClr val="4F6763"/>
                 </a:solidFill>
                 <a:latin typeface="Calibri"/>
               </a:rPr>
@@ -11536,7 +11826,7 @@
             <a:r>
               <a:rPr sz="1000" b="0">
                 <a:solidFill>
-                  <a:srgbClr val="71627C"/>
+                  <a:srgbClr val="4F6763"/>
                 </a:solidFill>
                 <a:latin typeface="Calibri"/>
               </a:rPr>
@@ -11596,7 +11886,7 @@
             <a:r>
               <a:rPr sz="3800" b="1">
                 <a:solidFill>
-                  <a:srgbClr val="3D2434"/>
+                  <a:srgbClr val="0D2D2A"/>
                 </a:solidFill>
                 <a:latin typeface="Cambria"/>
               </a:rPr>
@@ -11620,7 +11910,7 @@
             <a:avLst/>
           </a:prstGeom>
           <a:solidFill>
-            <a:srgbClr val="FAF6F9"/>
+            <a:srgbClr val="F5FAF9"/>
           </a:solidFill>
           <a:ln>
             <a:noFill/>
@@ -11662,7 +11952,7 @@
             <a:avLst/>
           </a:prstGeom>
           <a:solidFill>
-            <a:srgbClr val="E6007E"/>
+            <a:srgbClr val="0F766E"/>
           </a:solidFill>
           <a:ln>
             <a:noFill/>
@@ -11733,7 +12023,7 @@
             <a:r>
               <a:rPr sz="1900" b="1">
                 <a:solidFill>
-                  <a:srgbClr val="3D2434"/>
+                  <a:srgbClr val="0D2D2A"/>
                 </a:solidFill>
                 <a:latin typeface="Cambria"/>
               </a:rPr>
@@ -11775,11 +12065,11 @@
             <a:r>
               <a:rPr sz="1300" b="0">
                 <a:solidFill>
-                  <a:srgbClr val="3D2434"/>
-                </a:solidFill>
-                <a:latin typeface="Calibri"/>
-              </a:rPr>
-              <a:t>Load your Excel file (it stays on your computer).</a:t>
+                  <a:srgbClr val="0D2D2A"/>
+                </a:solidFill>
+                <a:latin typeface="Calibri"/>
+              </a:rPr>
+              <a:t>Load your Excel file (.xlsx or .xlsm) with Browse &amp; load Excel in the left sidebar, then pick the sheet. The file stays on your computer.</a:t>
             </a:r>
           </a:p>
           <a:p>
@@ -11794,7 +12084,7 @@
             <a:r>
               <a:rPr sz="1300" b="0">
                 <a:solidFill>
-                  <a:srgbClr val="3D2434"/>
+                  <a:srgbClr val="0D2D2A"/>
                 </a:solidFill>
                 <a:latin typeface="Calibri"/>
               </a:rPr>
@@ -11813,7 +12103,7 @@
             <a:r>
               <a:rPr sz="1300" b="0">
                 <a:solidFill>
-                  <a:srgbClr val="3D2434"/>
+                  <a:srgbClr val="0D2D2A"/>
                 </a:solidFill>
                 <a:latin typeface="Calibri"/>
               </a:rPr>
@@ -11832,7 +12122,7 @@
             <a:r>
               <a:rPr sz="1300" b="0">
                 <a:solidFill>
-                  <a:srgbClr val="3D2434"/>
+                  <a:srgbClr val="0D2D2A"/>
                 </a:solidFill>
                 <a:latin typeface="Calibri"/>
               </a:rPr>
@@ -11851,11 +12141,11 @@
             <a:r>
               <a:rPr sz="1300" b="0">
                 <a:solidFill>
-                  <a:srgbClr val="3D2434"/>
-                </a:solidFill>
-                <a:latin typeface="Calibri"/>
-              </a:rPr>
-              <a:t>Set the reference group — every comparison is made against it.</a:t>
+                  <a:srgbClr val="0D2D2A"/>
+                </a:solidFill>
+                <a:latin typeface="Calibri"/>
+              </a:rPr>
+              <a:t>Set the reference group. Matching, GEE, regression and the figures' versus-reference lines compare each group with it.</a:t>
             </a:r>
           </a:p>
           <a:p>
@@ -11870,7 +12160,7 @@
             <a:r>
               <a:rPr sz="1300" b="0">
                 <a:solidFill>
-                  <a:srgbClr val="3D2434"/>
+                  <a:srgbClr val="0D2D2A"/>
                 </a:solidFill>
                 <a:latin typeface="Calibri"/>
               </a:rPr>
@@ -11889,7 +12179,7 @@
             <a:r>
               <a:rPr sz="1300" b="0">
                 <a:solidFill>
-                  <a:srgbClr val="3D2434"/>
+                  <a:srgbClr val="0D2D2A"/>
                 </a:solidFill>
                 <a:latin typeface="Calibri"/>
               </a:rPr>
@@ -11913,7 +12203,7 @@
             <a:avLst/>
           </a:prstGeom>
           <a:solidFill>
-            <a:srgbClr val="FAF6F9"/>
+            <a:srgbClr val="F5FAF9"/>
           </a:solidFill>
           <a:ln>
             <a:noFill/>
@@ -11955,7 +12245,7 @@
             <a:avLst/>
           </a:prstGeom>
           <a:solidFill>
-            <a:srgbClr val="E6007E"/>
+            <a:srgbClr val="0F766E"/>
           </a:solidFill>
           <a:ln>
             <a:noFill/>
@@ -12026,7 +12316,7 @@
             <a:r>
               <a:rPr sz="1900" b="1">
                 <a:solidFill>
-                  <a:srgbClr val="3D2434"/>
+                  <a:srgbClr val="0D2D2A"/>
                 </a:solidFill>
                 <a:latin typeface="Cambria"/>
               </a:rPr>
@@ -12068,11 +12358,11 @@
             <a:r>
               <a:rPr sz="1300" b="0">
                 <a:solidFill>
-                  <a:srgbClr val="3D2434"/>
-                </a:solidFill>
-                <a:latin typeface="Calibri"/>
-              </a:rPr>
-              <a:t>Put each variable into Baseline, Preop or Outcome, and give it a type:</a:t>
+                  <a:srgbClr val="0D2D2A"/>
+                </a:solidFill>
+                <a:latin typeface="Calibri"/>
+              </a:rPr>
+              <a:t>Put each variable into Baseline, Preop / Intraop or Outcome, and give it a type:</a:t>
             </a:r>
           </a:p>
           <a:p>
@@ -12087,7 +12377,7 @@
             <a:r>
               <a:rPr sz="1300" b="0">
                 <a:solidFill>
-                  <a:srgbClr val="3D2434"/>
+                  <a:srgbClr val="0D2D2A"/>
                 </a:solidFill>
                 <a:latin typeface="Calibri"/>
               </a:rPr>
@@ -12106,7 +12396,7 @@
             <a:r>
               <a:rPr sz="1300" b="0">
                 <a:solidFill>
-                  <a:srgbClr val="3D2434"/>
+                  <a:srgbClr val="0D2D2A"/>
                 </a:solidFill>
                 <a:latin typeface="Calibri"/>
               </a:rPr>
@@ -12125,7 +12415,7 @@
             <a:r>
               <a:rPr sz="1300" b="0">
                 <a:solidFill>
-                  <a:srgbClr val="3D2434"/>
+                  <a:srgbClr val="0D2D2A"/>
                 </a:solidFill>
                 <a:latin typeface="Calibri"/>
               </a:rPr>
@@ -12144,7 +12434,7 @@
             <a:r>
               <a:rPr sz="1300" b="0">
                 <a:solidFill>
-                  <a:srgbClr val="3D2434"/>
+                  <a:srgbClr val="0D2D2A"/>
                 </a:solidFill>
                 <a:latin typeface="Calibri"/>
               </a:rPr>
@@ -12163,7 +12453,7 @@
             <a:r>
               <a:rPr sz="1300" b="0">
                 <a:solidFill>
-                  <a:srgbClr val="3D2434"/>
+                  <a:srgbClr val="0D2D2A"/>
                 </a:solidFill>
                 <a:latin typeface="Calibri"/>
               </a:rPr>
@@ -12182,11 +12472,11 @@
             <a:r>
               <a:rPr sz="1300" b="0">
                 <a:solidFill>
-                  <a:srgbClr val="3D2434"/>
-                </a:solidFill>
-                <a:latin typeface="Calibri"/>
-              </a:rPr>
-              <a:t>Also say how your file writes visual acuity: decimal, logMAR, Snellen or ETDRS letters.</a:t>
+                  <a:srgbClr val="0D2D2A"/>
+                </a:solidFill>
+                <a:latin typeface="Calibri"/>
+              </a:rPr>
+              <a:t>Also say how your file writes visual acuity: decimal, logMAR, Snellen or ETDRS letters. CF, HM, LP and NLP become missing. If most of a column cannot be read in that notation, the run stops and says why.</a:t>
             </a:r>
           </a:p>
         </p:txBody>
@@ -12224,7 +12514,7 @@
             <a:r>
               <a:rPr sz="1000" b="0">
                 <a:solidFill>
-                  <a:srgbClr val="71627C"/>
+                  <a:srgbClr val="4F6763"/>
                 </a:solidFill>
                 <a:latin typeface="Calibri"/>
               </a:rPr>
@@ -12266,7 +12556,7 @@
             <a:r>
               <a:rPr sz="1000" b="0">
                 <a:solidFill>
-                  <a:srgbClr val="71627C"/>
+                  <a:srgbClr val="4F6763"/>
                 </a:solidFill>
                 <a:latin typeface="Calibri"/>
               </a:rPr>
@@ -12326,7 +12616,7 @@
             <a:r>
               <a:rPr sz="3800" b="1">
                 <a:solidFill>
-                  <a:srgbClr val="3D2434"/>
+                  <a:srgbClr val="0D2D2A"/>
                 </a:solidFill>
                 <a:latin typeface="Cambria"/>
               </a:rPr>
@@ -12350,7 +12640,7 @@
             <a:avLst/>
           </a:prstGeom>
           <a:solidFill>
-            <a:srgbClr val="FAF6F9"/>
+            <a:srgbClr val="F5FAF9"/>
           </a:solidFill>
           <a:ln>
             <a:noFill/>
@@ -12392,7 +12682,7 @@
             <a:avLst/>
           </a:prstGeom>
           <a:solidFill>
-            <a:srgbClr val="E6007E"/>
+            <a:srgbClr val="0F766E"/>
           </a:solidFill>
           <a:ln>
             <a:noFill/>
@@ -12463,7 +12753,7 @@
             <a:r>
               <a:rPr sz="1900" b="1">
                 <a:solidFill>
-                  <a:srgbClr val="3D2434"/>
+                  <a:srgbClr val="0D2D2A"/>
                 </a:solidFill>
                 <a:latin typeface="Cambria"/>
               </a:rPr>
@@ -12505,11 +12795,11 @@
             <a:r>
               <a:rPr sz="1300" b="0">
                 <a:solidFill>
-                  <a:srgbClr val="3D2434"/>
-                </a:solidFill>
-                <a:latin typeface="Calibri"/>
-              </a:rPr>
-              <a:t>Add inclusion rules — age, follow-up, first treatment, cylinder limits, and so on.</a:t>
+                  <a:srgbClr val="0D2D2A"/>
+                </a:solidFill>
+                <a:latin typeface="Calibri"/>
+              </a:rPr>
+              <a:t>Add inclusion rules — age, follow-up, first treatment, cylinder limits, and so on. A blank cell passes a rule (add a notna rule to drop blanks), and rules use the values as recorded in your file.</a:t>
             </a:r>
           </a:p>
           <a:p>
@@ -12524,7 +12814,7 @@
             <a:r>
               <a:rPr sz="1300" b="0">
                 <a:solidFill>
-                  <a:srgbClr val="3D2434"/>
+                  <a:srgbClr val="0D2D2A"/>
                 </a:solidFill>
                 <a:latin typeface="Calibri"/>
               </a:rPr>
@@ -12543,7 +12833,7 @@
             <a:r>
               <a:rPr sz="1300" b="0">
                 <a:solidFill>
-                  <a:srgbClr val="3D2434"/>
+                  <a:srgbClr val="0D2D2A"/>
                 </a:solidFill>
                 <a:latin typeface="Calibri"/>
               </a:rPr>
@@ -12562,7 +12852,7 @@
             <a:r>
               <a:rPr sz="1300" b="0">
                 <a:solidFill>
-                  <a:srgbClr val="3D2434"/>
+                  <a:srgbClr val="0D2D2A"/>
                 </a:solidFill>
                 <a:latin typeface="Calibri"/>
               </a:rPr>
@@ -12581,11 +12871,11 @@
             <a:r>
               <a:rPr sz="1300" b="0">
                 <a:solidFill>
-                  <a:srgbClr val="3D2434"/>
-                </a:solidFill>
-                <a:latin typeface="Calibri"/>
-              </a:rPr>
-              <a:t>Subsets (e.g. PRK and LASIK) produce a separate full analysis each.</a:t>
+                  <a:srgbClr val="0D2D2A"/>
+                </a:solidFill>
+                <a:latin typeface="Calibri"/>
+              </a:rPr>
+              <a:t>Each enabled subset (e.g. PRK and LASIK) gets its own full analysis. Rows outside every subset are left out. The Workbooks setting can add, or give only, one pooled workbook.</a:t>
             </a:r>
           </a:p>
         </p:txBody>
@@ -12605,7 +12895,7 @@
             <a:avLst/>
           </a:prstGeom>
           <a:solidFill>
-            <a:srgbClr val="FAF6F9"/>
+            <a:srgbClr val="F5FAF9"/>
           </a:solidFill>
           <a:ln>
             <a:noFill/>
@@ -12647,7 +12937,7 @@
             <a:avLst/>
           </a:prstGeom>
           <a:solidFill>
-            <a:srgbClr val="E6007E"/>
+            <a:srgbClr val="0F766E"/>
           </a:solidFill>
           <a:ln>
             <a:noFill/>
@@ -12718,7 +13008,7 @@
             <a:r>
               <a:rPr sz="1900" b="1">
                 <a:solidFill>
-                  <a:srgbClr val="3D2434"/>
+                  <a:srgbClr val="0D2D2A"/>
                 </a:solidFill>
                 <a:latin typeface="Cambria"/>
               </a:rPr>
@@ -12760,7 +13050,7 @@
             <a:r>
               <a:rPr sz="1300" b="0">
                 <a:solidFill>
-                  <a:srgbClr val="3D2434"/>
+                  <a:srgbClr val="0D2D2A"/>
                 </a:solidFill>
                 <a:latin typeface="Calibri"/>
               </a:rPr>
@@ -12779,7 +13069,7 @@
             <a:r>
               <a:rPr sz="1300" b="0">
                 <a:solidFill>
-                  <a:srgbClr val="3D2434"/>
+                  <a:srgbClr val="0D2D2A"/>
                 </a:solidFill>
                 <a:latin typeface="Calibri"/>
               </a:rPr>
@@ -12798,11 +13088,11 @@
             <a:r>
               <a:rPr sz="1300" b="0">
                 <a:solidFill>
-                  <a:srgbClr val="3D2434"/>
-                </a:solidFill>
-                <a:latin typeface="Calibri"/>
-              </a:rPr>
-              <a:t>Choose the covariates to match on and, for nearest neighbour, the ratio and the caliper. A live preview shows how many eyes match before you commit.</a:t>
+                  <a:srgbClr val="0D2D2A"/>
+                </a:solidFill>
+                <a:latin typeface="Calibri"/>
+              </a:rPr>
+              <a:t>Choose the covariates to match on and, for nearest neighbour, the ratio and the caliper (default 1:1, caliper 0.2 SD of the propensity score). For nearest neighbour a live preview shows how many eyes match before you run. The other three methods are not previewed.</a:t>
             </a:r>
           </a:p>
           <a:p>
@@ -12817,7 +13107,7 @@
             <a:r>
               <a:rPr sz="1300" b="0">
                 <a:solidFill>
-                  <a:srgbClr val="3D2434"/>
+                  <a:srgbClr val="0D2D2A"/>
                 </a:solidFill>
                 <a:latin typeface="Calibri"/>
               </a:rPr>
@@ -12836,11 +13126,11 @@
             <a:r>
               <a:rPr sz="1300" b="0">
                 <a:solidFill>
-                  <a:srgbClr val="3D2434"/>
-                </a:solidFill>
-                <a:latin typeface="Calibri"/>
-              </a:rPr>
-              <a:t>Balance is reported so you can show the groups became comparable.</a:t>
+                  <a:srgbClr val="0D2D2A"/>
+                </a:solidFill>
+                <a:latin typeface="Calibri"/>
+              </a:rPr>
+              <a:t>Balance is reported on each pairing's PSM sheet and in its love plot, so you can show the groups became comparable.</a:t>
             </a:r>
           </a:p>
         </p:txBody>
@@ -12878,7 +13168,7 @@
             <a:r>
               <a:rPr sz="1000" b="0">
                 <a:solidFill>
-                  <a:srgbClr val="71627C"/>
+                  <a:srgbClr val="4F6763"/>
                 </a:solidFill>
                 <a:latin typeface="Calibri"/>
               </a:rPr>
@@ -12920,7 +13210,7 @@
             <a:r>
               <a:rPr sz="1000" b="0">
                 <a:solidFill>
-                  <a:srgbClr val="71627C"/>
+                  <a:srgbClr val="4F6763"/>
                 </a:solidFill>
                 <a:latin typeface="Calibri"/>
               </a:rPr>
@@ -12980,7 +13270,7 @@
             <a:r>
               <a:rPr sz="3800" b="1">
                 <a:solidFill>
-                  <a:srgbClr val="3D2434"/>
+                  <a:srgbClr val="0D2D2A"/>
                 </a:solidFill>
                 <a:latin typeface="Cambria"/>
               </a:rPr>
@@ -13022,7 +13312,7 @@
             <a:r>
               <a:rPr sz="1500" b="0">
                 <a:solidFill>
-                  <a:srgbClr val="71627C"/>
+                  <a:srgbClr val="4F6763"/>
                 </a:solidFill>
                 <a:latin typeface="Calibri"/>
               </a:rPr>
@@ -13046,7 +13336,7 @@
             <a:avLst/>
           </a:prstGeom>
           <a:solidFill>
-            <a:srgbClr val="FDE7F3"/>
+            <a:srgbClr val="E6F5F3"/>
           </a:solidFill>
           <a:ln>
             <a:noFill/>
@@ -13106,7 +13396,7 @@
             <a:r>
               <a:rPr sz="1400" b="1">
                 <a:solidFill>
-                  <a:srgbClr val="3D2434"/>
+                  <a:srgbClr val="0D2D2A"/>
                 </a:solidFill>
                 <a:latin typeface="Calibri"/>
               </a:rPr>
@@ -13115,7 +13405,7 @@
             <a:r>
               <a:rPr sz="1400" b="0">
                 <a:solidFill>
-                  <a:srgbClr val="3D2434"/>
+                  <a:srgbClr val="0D2D2A"/>
                 </a:solidFill>
                 <a:latin typeface="Calibri"/>
               </a:rPr>
@@ -13132,14 +13422,14 @@
         </p:nvSpPr>
         <p:spPr>
           <a:xfrm>
-            <a:off x="868680" y="3739896"/>
+            <a:off x="868680" y="3236976"/>
             <a:ext cx="347472" cy="347472"/>
           </a:xfrm>
           <a:prstGeom prst="ellipse">
             <a:avLst/>
           </a:prstGeom>
           <a:solidFill>
-            <a:srgbClr val="E6007E"/>
+            <a:srgbClr val="0F766E"/>
           </a:solidFill>
           <a:ln>
             <a:noFill/>
@@ -13185,7 +13475,7 @@
         </p:nvSpPr>
         <p:spPr>
           <a:xfrm>
-            <a:off x="1371600" y="3703320"/>
+            <a:off x="1371600" y="3200400"/>
             <a:ext cx="3520440" cy="548640"/>
           </a:xfrm>
           <a:prstGeom prst="rect">
@@ -13210,7 +13500,7 @@
             <a:r>
               <a:rPr sz="1350" b="1">
                 <a:solidFill>
-                  <a:srgbClr val="3D2434"/>
+                  <a:srgbClr val="0D2D2A"/>
                 </a:solidFill>
                 <a:latin typeface="Calibri"/>
               </a:rPr>
@@ -13227,8 +13517,8 @@
         </p:nvSpPr>
         <p:spPr>
           <a:xfrm>
-            <a:off x="5029200" y="3703320"/>
-            <a:ext cx="6400800" cy="640080"/>
+            <a:off x="5029200" y="3200400"/>
+            <a:ext cx="6400800" cy="548640"/>
           </a:xfrm>
           <a:prstGeom prst="rect">
             <a:avLst/>
@@ -13252,7 +13542,7 @@
             <a:r>
               <a:rPr sz="1250" b="0">
                 <a:solidFill>
-                  <a:srgbClr val="71627C"/>
+                  <a:srgbClr val="4F6763"/>
                 </a:solidFill>
                 <a:latin typeface="Calibri"/>
               </a:rPr>
@@ -13269,14 +13559,14 @@
         </p:nvSpPr>
         <p:spPr>
           <a:xfrm>
-            <a:off x="868680" y="4517136"/>
+            <a:off x="868680" y="3858768"/>
             <a:ext cx="347472" cy="347472"/>
           </a:xfrm>
           <a:prstGeom prst="ellipse">
             <a:avLst/>
           </a:prstGeom>
           <a:solidFill>
-            <a:srgbClr val="E6007E"/>
+            <a:srgbClr val="0F766E"/>
           </a:solidFill>
           <a:ln>
             <a:noFill/>
@@ -13322,7 +13612,7 @@
         </p:nvSpPr>
         <p:spPr>
           <a:xfrm>
-            <a:off x="1371600" y="4480559"/>
+            <a:off x="1371600" y="3822191"/>
             <a:ext cx="3520440" cy="548640"/>
           </a:xfrm>
           <a:prstGeom prst="rect">
@@ -13347,7 +13637,7 @@
             <a:r>
               <a:rPr sz="1350" b="1">
                 <a:solidFill>
-                  <a:srgbClr val="3D2434"/>
+                  <a:srgbClr val="0D2D2A"/>
                 </a:solidFill>
                 <a:latin typeface="Calibri"/>
               </a:rPr>
@@ -13364,8 +13654,8 @@
         </p:nvSpPr>
         <p:spPr>
           <a:xfrm>
-            <a:off x="5029200" y="4480559"/>
-            <a:ext cx="6400800" cy="640080"/>
+            <a:off x="5029200" y="3822191"/>
+            <a:ext cx="6400800" cy="548640"/>
           </a:xfrm>
           <a:prstGeom prst="rect">
             <a:avLst/>
@@ -13389,11 +13679,11 @@
             <a:r>
               <a:rPr sz="1250" b="0">
                 <a:solidFill>
-                  <a:srgbClr val="71627C"/>
-                </a:solidFill>
-                <a:latin typeface="Calibri"/>
-              </a:rPr>
-              <a:t>Regression adjustment after matching: adjust the outcome model for whatever matching left imbalanced — the strongest option the app offers.</a:t>
+                  <a:srgbClr val="4F6763"/>
+                </a:solidFill>
+                <a:latin typeface="Calibri"/>
+              </a:rPr>
+              <a:t>Set Run on to Matched cohort (or Both) on the Regression tab to adjust the outcome model for whatever matching left imbalanced.</a:t>
             </a:r>
           </a:p>
         </p:txBody>
@@ -13406,14 +13696,14 @@
         </p:nvSpPr>
         <p:spPr>
           <a:xfrm>
-            <a:off x="868680" y="5294375"/>
+            <a:off x="868680" y="4480559"/>
             <a:ext cx="347472" cy="347472"/>
           </a:xfrm>
           <a:prstGeom prst="ellipse">
             <a:avLst/>
           </a:prstGeom>
           <a:solidFill>
-            <a:srgbClr val="E6007E"/>
+            <a:srgbClr val="0F766E"/>
           </a:solidFill>
           <a:ln>
             <a:noFill/>
@@ -13459,7 +13749,7 @@
         </p:nvSpPr>
         <p:spPr>
           <a:xfrm>
-            <a:off x="1371600" y="5257799"/>
+            <a:off x="1371600" y="4443983"/>
             <a:ext cx="3520440" cy="548640"/>
           </a:xfrm>
           <a:prstGeom prst="rect">
@@ -13484,7 +13774,7 @@
             <a:r>
               <a:rPr sz="1350" b="1">
                 <a:solidFill>
-                  <a:srgbClr val="3D2434"/>
+                  <a:srgbClr val="0D2D2A"/>
                 </a:solidFill>
                 <a:latin typeface="Calibri"/>
               </a:rPr>
@@ -13501,8 +13791,8 @@
         </p:nvSpPr>
         <p:spPr>
           <a:xfrm>
-            <a:off x="5029200" y="5257799"/>
-            <a:ext cx="6400800" cy="640080"/>
+            <a:off x="5029200" y="4443983"/>
+            <a:ext cx="6400800" cy="548640"/>
           </a:xfrm>
           <a:prstGeom prst="rect">
             <a:avLst/>
@@ -13526,7 +13816,7 @@
             <a:r>
               <a:rPr sz="1250" b="0">
                 <a:solidFill>
-                  <a:srgbClr val="71627C"/>
+                  <a:srgbClr val="4F6763"/>
                 </a:solidFill>
                 <a:latin typeface="Calibri"/>
               </a:rPr>
@@ -13537,7 +13827,281 @@
       </p:sp>
       <p:sp>
         <p:nvSpPr>
-          <p:cNvPr id="15" name="TextBox 14"/>
+          <p:cNvPr id="15" name="Oval 14"/>
+          <p:cNvSpPr/>
+          <p:nvPr/>
+        </p:nvSpPr>
+        <p:spPr>
+          <a:xfrm>
+            <a:off x="868680" y="5102351"/>
+            <a:ext cx="347472" cy="347472"/>
+          </a:xfrm>
+          <a:prstGeom prst="ellipse">
+            <a:avLst/>
+          </a:prstGeom>
+          <a:solidFill>
+            <a:srgbClr val="0F766E"/>
+          </a:solidFill>
+          <a:ln>
+            <a:noFill/>
+          </a:ln>
+          <a:effectLst/>
+        </p:spPr>
+        <p:style>
+          <a:lnRef idx="1">
+            <a:schemeClr val="accent1"/>
+          </a:lnRef>
+          <a:fillRef idx="3">
+            <a:schemeClr val="accent1"/>
+          </a:fillRef>
+          <a:effectRef idx="2">
+            <a:schemeClr val="accent1"/>
+          </a:effectRef>
+          <a:fontRef idx="minor">
+            <a:schemeClr val="lt1"/>
+          </a:fontRef>
+        </p:style>
+        <p:txBody>
+          <a:bodyPr rtlCol="0" anchor="ctr" wrap="none" lIns="0" rIns="0" tIns="0" bIns="0"/>
+          <a:lstStyle/>
+          <a:p>
+            <a:pPr algn="ctr"/>
+            <a:r>
+              <a:rPr sz="1500" b="1">
+                <a:solidFill>
+                  <a:srgbClr val="FFFFFF"/>
+                </a:solidFill>
+                <a:latin typeface="Calibri"/>
+              </a:rPr>
+              <a:t>•</a:t>
+            </a:r>
+          </a:p>
+        </p:txBody>
+      </p:sp>
+      <p:sp>
+        <p:nvSpPr>
+          <p:cNvPr id="16" name="TextBox 15"/>
+          <p:cNvSpPr txBox="1"/>
+          <p:nvPr/>
+        </p:nvSpPr>
+        <p:spPr>
+          <a:xfrm>
+            <a:off x="1371600" y="5065775"/>
+            <a:ext cx="3520440" cy="548640"/>
+          </a:xfrm>
+          <a:prstGeom prst="rect">
+            <a:avLst/>
+          </a:prstGeom>
+          <a:noFill/>
+        </p:spPr>
+        <p:txBody>
+          <a:bodyPr wrap="square" lIns="0" rIns="0" tIns="0" bIns="0" anchor="t">
+            <a:spAutoFit/>
+          </a:bodyPr>
+          <a:lstStyle/>
+          <a:p>
+            <a:pPr algn="l">
+              <a:lnSpc>
+                <a:spcPct val="115000"/>
+              </a:lnSpc>
+              <a:spcAft>
+                <a:spcPts val="600"/>
+              </a:spcAft>
+            </a:pPr>
+            <a:r>
+              <a:rPr sz="1350" b="1">
+                <a:solidFill>
+                  <a:srgbClr val="0D2D2A"/>
+                </a:solidFill>
+                <a:latin typeface="Calibri"/>
+              </a:rPr>
+              <a:t>Small groups carry a caution</a:t>
+            </a:r>
+          </a:p>
+        </p:txBody>
+      </p:sp>
+      <p:sp>
+        <p:nvSpPr>
+          <p:cNvPr id="17" name="TextBox 16"/>
+          <p:cNvSpPr txBox="1"/>
+          <p:nvPr/>
+        </p:nvSpPr>
+        <p:spPr>
+          <a:xfrm>
+            <a:off x="5029200" y="5065775"/>
+            <a:ext cx="6400800" cy="548640"/>
+          </a:xfrm>
+          <a:prstGeom prst="rect">
+            <a:avLst/>
+          </a:prstGeom>
+          <a:noFill/>
+        </p:spPr>
+        <p:txBody>
+          <a:bodyPr wrap="square" lIns="0" rIns="0" tIns="0" bIns="0" anchor="t">
+            <a:spAutoFit/>
+          </a:bodyPr>
+          <a:lstStyle/>
+          <a:p>
+            <a:pPr algn="l">
+              <a:lnSpc>
+                <a:spcPct val="115000"/>
+              </a:lnSpc>
+              <a:spcAft>
+                <a:spcPts val="600"/>
+              </a:spcAft>
+            </a:pPr>
+            <a:r>
+              <a:rPr sz="1250" b="0">
+                <a:solidFill>
+                  <a:srgbClr val="4F6763"/>
+                </a:solidFill>
+                <a:latin typeface="Calibri"/>
+              </a:rPr>
+              <a:t>A clustered model needs at least 6 eyes and 3 patients, otherwise it reports Not estimable. A group with 2-9 patients gets a caution under Check before using the results.</a:t>
+            </a:r>
+          </a:p>
+        </p:txBody>
+      </p:sp>
+      <p:sp>
+        <p:nvSpPr>
+          <p:cNvPr id="18" name="Oval 17"/>
+          <p:cNvSpPr/>
+          <p:nvPr/>
+        </p:nvSpPr>
+        <p:spPr>
+          <a:xfrm>
+            <a:off x="868680" y="5724143"/>
+            <a:ext cx="347472" cy="347472"/>
+          </a:xfrm>
+          <a:prstGeom prst="ellipse">
+            <a:avLst/>
+          </a:prstGeom>
+          <a:solidFill>
+            <a:srgbClr val="0F766E"/>
+          </a:solidFill>
+          <a:ln>
+            <a:noFill/>
+          </a:ln>
+          <a:effectLst/>
+        </p:spPr>
+        <p:style>
+          <a:lnRef idx="1">
+            <a:schemeClr val="accent1"/>
+          </a:lnRef>
+          <a:fillRef idx="3">
+            <a:schemeClr val="accent1"/>
+          </a:fillRef>
+          <a:effectRef idx="2">
+            <a:schemeClr val="accent1"/>
+          </a:effectRef>
+          <a:fontRef idx="minor">
+            <a:schemeClr val="lt1"/>
+          </a:fontRef>
+        </p:style>
+        <p:txBody>
+          <a:bodyPr rtlCol="0" anchor="ctr" wrap="none" lIns="0" rIns="0" tIns="0" bIns="0"/>
+          <a:lstStyle/>
+          <a:p>
+            <a:pPr algn="ctr"/>
+            <a:r>
+              <a:rPr sz="1500" b="1">
+                <a:solidFill>
+                  <a:srgbClr val="FFFFFF"/>
+                </a:solidFill>
+                <a:latin typeface="Calibri"/>
+              </a:rPr>
+              <a:t>•</a:t>
+            </a:r>
+          </a:p>
+        </p:txBody>
+      </p:sp>
+      <p:sp>
+        <p:nvSpPr>
+          <p:cNvPr id="19" name="TextBox 18"/>
+          <p:cNvSpPr txBox="1"/>
+          <p:nvPr/>
+        </p:nvSpPr>
+        <p:spPr>
+          <a:xfrm>
+            <a:off x="1371600" y="5687567"/>
+            <a:ext cx="3520440" cy="548640"/>
+          </a:xfrm>
+          <a:prstGeom prst="rect">
+            <a:avLst/>
+          </a:prstGeom>
+          <a:noFill/>
+        </p:spPr>
+        <p:txBody>
+          <a:bodyPr wrap="square" lIns="0" rIns="0" tIns="0" bIns="0" anchor="t">
+            <a:spAutoFit/>
+          </a:bodyPr>
+          <a:lstStyle/>
+          <a:p>
+            <a:pPr algn="l">
+              <a:lnSpc>
+                <a:spcPct val="115000"/>
+              </a:lnSpc>
+              <a:spcAft>
+                <a:spcPts val="600"/>
+              </a:spcAft>
+            </a:pPr>
+            <a:r>
+              <a:rPr sz="1350" b="1">
+                <a:solidFill>
+                  <a:srgbClr val="0D2D2A"/>
+                </a:solidFill>
+                <a:latin typeface="Calibri"/>
+              </a:rPr>
+              <a:t>Pick the GEE cohort</a:t>
+            </a:r>
+          </a:p>
+        </p:txBody>
+      </p:sp>
+      <p:sp>
+        <p:nvSpPr>
+          <p:cNvPr id="20" name="TextBox 19"/>
+          <p:cNvSpPr txBox="1"/>
+          <p:nvPr/>
+        </p:nvSpPr>
+        <p:spPr>
+          <a:xfrm>
+            <a:off x="5029200" y="5687567"/>
+            <a:ext cx="6400800" cy="548640"/>
+          </a:xfrm>
+          <a:prstGeom prst="rect">
+            <a:avLst/>
+          </a:prstGeom>
+          <a:noFill/>
+        </p:spPr>
+        <p:txBody>
+          <a:bodyPr wrap="square" lIns="0" rIns="0" tIns="0" bIns="0" anchor="t">
+            <a:spAutoFit/>
+          </a:bodyPr>
+          <a:lstStyle/>
+          <a:p>
+            <a:pPr algn="l">
+              <a:lnSpc>
+                <a:spcPct val="115000"/>
+              </a:lnSpc>
+              <a:spcAft>
+                <a:spcPts val="600"/>
+              </a:spcAft>
+            </a:pPr>
+            <a:r>
+              <a:rPr sz="1250" b="0">
+                <a:solidFill>
+                  <a:srgbClr val="4F6763"/>
+                </a:solidFill>
+                <a:latin typeface="Calibri"/>
+              </a:rPr>
+              <a:t>On the GEE tab, run GEE on the matched cohort (the default), the unmatched one or both. Main GEE is the group effect alone. Adjusted GEE adds the covariates you list there.</a:t>
+            </a:r>
+          </a:p>
+        </p:txBody>
+      </p:sp>
+      <p:sp>
+        <p:nvSpPr>
+          <p:cNvPr id="21" name="TextBox 20"/>
           <p:cNvSpPr txBox="1"/>
           <p:nvPr/>
         </p:nvSpPr>
@@ -13568,7 +14132,7 @@
             <a:r>
               <a:rPr sz="1000" b="0">
                 <a:solidFill>
-                  <a:srgbClr val="71627C"/>
+                  <a:srgbClr val="4F6763"/>
                 </a:solidFill>
                 <a:latin typeface="Calibri"/>
               </a:rPr>
@@ -13579,7 +14143,7 @@
       </p:sp>
       <p:sp>
         <p:nvSpPr>
-          <p:cNvPr id="16" name="TextBox 15"/>
+          <p:cNvPr id="22" name="TextBox 21"/>
           <p:cNvSpPr txBox="1"/>
           <p:nvPr/>
         </p:nvSpPr>
@@ -13610,7 +14174,7 @@
             <a:r>
               <a:rPr sz="1000" b="0">
                 <a:solidFill>
-                  <a:srgbClr val="71627C"/>
+                  <a:srgbClr val="4F6763"/>
                 </a:solidFill>
                 <a:latin typeface="Calibri"/>
               </a:rPr>

</xml_diff>